<commit_message>
TWY E Rev P08: allocate the five days across the three locations
The programme now runs one location front at a time instead of interleaving
trades across sites: LOC-01 over Days 1-3 (11 No. fittings, approx. 300 m of
cut), LOC-03 on Day 4 (4 No., approx. 95 m), LOC-02 on Day 5 (1 No., approx.
24 m). Each location is cut, cabled, tested and sealed before the next opens,
so it can be released back rather than leaving three part-finished fronts.

Two items still span all three locations and are shown as such: the setting-out
on Day 1, taken in one survey visit, and the circuit testing and commissioning
on Day 5, which cannot complete until every location is cabled because the
circuits run through all three.

Day-box headlines are checked against the box width so none wrap.

Co-Authored-By: Claude Opus 5 <noreply@anthropic.com>
Claude-Session: https://claude.ai/code/session_01VJQm9FRnDf8JGAAWEgrXR2
</commit_message>
<xml_diff>
--- a/skills/zia-mta-basemap/examples/twy-e-asbuilt-ducts/out/AUH-SK-AGL-TWYE-001 - TWY E Shop Drawings - ZIA Rev P08 FINAL.pptx
+++ b/skills/zia-mta-basemap/examples/twy-e-asbuilt-ducts/out/AUH-SK-AGL-TWYE-001 - TWY E Shop Drawings - ZIA Rev P08 FINAL.pptx
@@ -53391,7 +53391,7 @@
                 </a:solidFill>
                 <a:latin typeface="Arial"/>
               </a:rPr>
-              <a:t>LOC-01</a:t>
+              <a:t>LOCATION 1  ·  SHEET 1001</a:t>
             </a:r>
           </a:p>
         </p:txBody>
@@ -53547,7 +53547,7 @@
                 </a:solidFill>
                 <a:latin typeface="Arial"/>
               </a:rPr>
-              <a:t>LOC-01</a:t>
+              <a:t>LOCATION 1  ·  SHEET 1001</a:t>
             </a:r>
           </a:p>
         </p:txBody>
@@ -53687,7 +53687,7 @@
                 </a:solidFill>
                 <a:latin typeface="Arial"/>
               </a:rPr>
-              <a:t>SAW CUT &amp; BASES · FIRST CABLE</a:t>
+              <a:t>CABLE, TEST &amp; REINSTATEMENT</a:t>
             </a:r>
           </a:p>
           <a:p>
@@ -53703,7 +53703,7 @@
                 </a:solidFill>
                 <a:latin typeface="Arial"/>
               </a:rPr>
-              <a:t>LOC-02 / 03 · LOC-01</a:t>
+              <a:t>LOCATION 1  ·  SHEET 1001</a:t>
             </a:r>
           </a:p>
         </p:txBody>
@@ -53843,7 +53843,7 @@
                 </a:solidFill>
                 <a:latin typeface="Arial"/>
               </a:rPr>
-              <a:t>CABLE, TERMINATION &amp; TESTING</a:t>
+              <a:t>FULL CYCLE — CUT TO SEALED</a:t>
             </a:r>
           </a:p>
           <a:p>
@@ -53859,7 +53859,7 @@
                 </a:solidFill>
                 <a:latin typeface="Arial"/>
               </a:rPr>
-              <a:t>ALL LOCATIONS</a:t>
+              <a:t>LOCATION 3  ·  SHEET 1003</a:t>
             </a:r>
           </a:p>
         </p:txBody>
@@ -53999,7 +53999,7 @@
                 </a:solidFill>
                 <a:latin typeface="Arial"/>
               </a:rPr>
-              <a:t>REINSTATEMENT, T&amp;C &amp; HANDOVER</a:t>
+              <a:t>FULL CYCLE + T&amp;C &amp; HANDOVER</a:t>
             </a:r>
           </a:p>
           <a:p>
@@ -54015,7 +54015,7 @@
                 </a:solidFill>
                 <a:latin typeface="Arial"/>
               </a:rPr>
-              <a:t>ALL LOCATIONS</a:t>
+              <a:t>LOCATION 2  ·  SHEET 1002</a:t>
             </a:r>
           </a:p>
         </p:txBody>
@@ -54029,7 +54029,7 @@
         <p:spPr>
           <a:xfrm>
             <a:off x="457200" y="2129790"/>
-            <a:ext cx="14173200" cy="5268843"/>
+            <a:ext cx="14173200" cy="4475720"/>
           </a:xfrm>
           <a:prstGeom prst="rect">
             <a:avLst/>
@@ -54115,7 +54115,7 @@
         </p:nvGraphicFramePr>
         <p:xfrm>
           <a:off x="603504" y="2605278"/>
-          <a:ext cx="13880592" cy="4656195"/>
+          <a:ext cx="13880592" cy="3863072"/>
         </p:xfrm>
         <a:graphic>
           <a:graphicData uri="http://schemas.openxmlformats.org/drawingml/2006/table">
@@ -54131,7 +54131,7 @@
                 <a:gridCol w="1828800"/>
                 <a:gridCol w="4142232"/>
               </a:tblGrid>
-              <a:tr h="310413">
+              <a:tr h="241442">
                 <a:tc>
                   <a:txBody>
                     <a:bodyPr/>
@@ -54385,7 +54385,7 @@
                   </a:tcPr>
                 </a:tc>
               </a:tr>
-              <a:tr h="310413">
+              <a:tr h="241442">
                 <a:tc>
                   <a:txBody>
                     <a:bodyPr/>
@@ -54440,7 +54440,7 @@
                           </a:solidFill>
                           <a:latin typeface="Arial"/>
                         </a:rPr>
-                        <a:t>Setting-out from the civil survey points; area protection and lighting</a:t>
+                        <a:t>Setting-out from the civil survey points — all three locations in one visit</a:t>
                       </a:r>
                     </a:p>
                   </a:txBody>
@@ -54608,7 +54608,7 @@
                           </a:solidFill>
                           <a:latin typeface="Arial"/>
                         </a:rPr>
-                        <a:t>Field points confirmed and marked</a:t>
+                        <a:t>Field points confirmed and marked at all three</a:t>
                       </a:r>
                     </a:p>
                   </a:txBody>
@@ -54639,7 +54639,7 @@
                   </a:tcPr>
                 </a:tc>
               </a:tr>
-              <a:tr h="310413">
+              <a:tr h="241442">
                 <a:tc>
                   <a:txBody>
                     <a:bodyPr/>
@@ -54736,7 +54736,7 @@
                           </a:solidFill>
                           <a:latin typeface="Arial"/>
                         </a:rPr>
-                        <a:t>LOC-01</a:t>
+                        <a:t>LOC-01 · 1001</a:t>
                       </a:r>
                     </a:p>
                   </a:txBody>
@@ -54893,7 +54893,7 @@
                   </a:tcPr>
                 </a:tc>
               </a:tr>
-              <a:tr h="310413">
+              <a:tr h="241442">
                 <a:tc>
                   <a:txBody>
                     <a:bodyPr/>
@@ -54990,7 +54990,7 @@
                           </a:solidFill>
                           <a:latin typeface="Arial"/>
                         </a:rPr>
-                        <a:t>LOC-01</a:t>
+                        <a:t>LOC-01 · 1001</a:t>
                       </a:r>
                     </a:p>
                   </a:txBody>
@@ -55147,7 +55147,7 @@
                   </a:tcPr>
                 </a:tc>
               </a:tr>
-              <a:tr h="310413">
+              <a:tr h="241442">
                 <a:tc>
                   <a:txBody>
                     <a:bodyPr/>
@@ -55244,7 +55244,7 @@
                           </a:solidFill>
                           <a:latin typeface="Arial"/>
                         </a:rPr>
-                        <a:t>LOC-01</a:t>
+                        <a:t>LOC-01 · 1001</a:t>
                       </a:r>
                     </a:p>
                   </a:txBody>
@@ -55401,7 +55401,7 @@
                   </a:tcPr>
                 </a:tc>
               </a:tr>
-              <a:tr h="310413">
+              <a:tr h="241442">
                 <a:tc>
                   <a:txBody>
                     <a:bodyPr/>
@@ -55441,6 +55441,768 @@
                     </a:lnL>
                     <a:solidFill>
                       <a:srgbClr val="FFFFFF"/>
+                    </a:solidFill>
+                  </a:tcPr>
+                </a:tc>
+                <a:tc>
+                  <a:txBody>
+                    <a:bodyPr/>
+                    <a:lstStyle/>
+                    <a:p>
+                      <a:r>
+                        <a:rPr sz="800" b="0" i="0">
+                          <a:solidFill>
+                            <a:srgbClr val="1F2937"/>
+                          </a:solidFill>
+                          <a:latin typeface="Arial"/>
+                        </a:rPr>
+                        <a:t>Lay new secondary cable through the saw cut — no joints, manhole to light</a:t>
+                      </a:r>
+                    </a:p>
+                  </a:txBody>
+                  <a:tcPr marL="91440" marR="91440" marT="45720" marB="45720">
+                    <a:lnB w="6350" cap="flat" cmpd="sng" algn="ctr">
+                      <a:solidFill>
+                        <a:srgbClr val="C8CDD3"/>
+                      </a:solidFill>
+                    </a:lnB>
+                    <a:lnT w="6350" cap="flat" cmpd="sng" algn="ctr">
+                      <a:solidFill>
+                        <a:srgbClr val="C8CDD3"/>
+                      </a:solidFill>
+                    </a:lnT>
+                    <a:lnR w="6350" cap="flat" cmpd="sng" algn="ctr">
+                      <a:solidFill>
+                        <a:srgbClr val="C8CDD3"/>
+                      </a:solidFill>
+                    </a:lnR>
+                    <a:lnL w="6350" cap="flat" cmpd="sng" algn="ctr">
+                      <a:solidFill>
+                        <a:srgbClr val="C8CDD3"/>
+                      </a:solidFill>
+                    </a:lnL>
+                    <a:solidFill>
+                      <a:srgbClr val="FFFFFF"/>
+                    </a:solidFill>
+                  </a:tcPr>
+                </a:tc>
+                <a:tc>
+                  <a:txBody>
+                    <a:bodyPr/>
+                    <a:lstStyle/>
+                    <a:p>
+                      <a:r>
+                        <a:rPr sz="800" b="0" i="0">
+                          <a:solidFill>
+                            <a:srgbClr val="1F2937"/>
+                          </a:solidFill>
+                          <a:latin typeface="Arial"/>
+                        </a:rPr>
+                        <a:t>LOC-01 · 1001</a:t>
+                      </a:r>
+                    </a:p>
+                  </a:txBody>
+                  <a:tcPr marL="91440" marR="91440" marT="45720" marB="45720">
+                    <a:lnB w="6350" cap="flat" cmpd="sng" algn="ctr">
+                      <a:solidFill>
+                        <a:srgbClr val="C8CDD3"/>
+                      </a:solidFill>
+                    </a:lnB>
+                    <a:lnT w="6350" cap="flat" cmpd="sng" algn="ctr">
+                      <a:solidFill>
+                        <a:srgbClr val="C8CDD3"/>
+                      </a:solidFill>
+                    </a:lnT>
+                    <a:lnR w="6350" cap="flat" cmpd="sng" algn="ctr">
+                      <a:solidFill>
+                        <a:srgbClr val="C8CDD3"/>
+                      </a:solidFill>
+                    </a:lnR>
+                    <a:lnL w="6350" cap="flat" cmpd="sng" algn="ctr">
+                      <a:solidFill>
+                        <a:srgbClr val="C8CDD3"/>
+                      </a:solidFill>
+                    </a:lnL>
+                    <a:solidFill>
+                      <a:srgbClr val="FFFFFF"/>
+                    </a:solidFill>
+                  </a:tcPr>
+                </a:tc>
+                <a:tc>
+                  <a:txBody>
+                    <a:bodyPr/>
+                    <a:lstStyle/>
+                    <a:p>
+                      <a:r>
+                        <a:rPr sz="800" b="0" i="0">
+                          <a:solidFill>
+                            <a:srgbClr val="1F2937"/>
+                          </a:solidFill>
+                          <a:latin typeface="Arial"/>
+                        </a:rPr>
+                        <a:t>11 No. runs</a:t>
+                      </a:r>
+                    </a:p>
+                  </a:txBody>
+                  <a:tcPr marL="91440" marR="91440" marT="45720" marB="45720">
+                    <a:lnB w="6350" cap="flat" cmpd="sng" algn="ctr">
+                      <a:solidFill>
+                        <a:srgbClr val="C8CDD3"/>
+                      </a:solidFill>
+                    </a:lnB>
+                    <a:lnT w="6350" cap="flat" cmpd="sng" algn="ctr">
+                      <a:solidFill>
+                        <a:srgbClr val="C8CDD3"/>
+                      </a:solidFill>
+                    </a:lnT>
+                    <a:lnR w="6350" cap="flat" cmpd="sng" algn="ctr">
+                      <a:solidFill>
+                        <a:srgbClr val="C8CDD3"/>
+                      </a:solidFill>
+                    </a:lnR>
+                    <a:lnL w="6350" cap="flat" cmpd="sng" algn="ctr">
+                      <a:solidFill>
+                        <a:srgbClr val="C8CDD3"/>
+                      </a:solidFill>
+                    </a:lnL>
+                    <a:solidFill>
+                      <a:srgbClr val="FFFFFF"/>
+                    </a:solidFill>
+                  </a:tcPr>
+                </a:tc>
+                <a:tc>
+                  <a:txBody>
+                    <a:bodyPr/>
+                    <a:lstStyle/>
+                    <a:p>
+                      <a:r>
+                        <a:rPr sz="800" b="0" i="0">
+                          <a:solidFill>
+                            <a:srgbClr val="1F2937"/>
+                          </a:solidFill>
+                          <a:latin typeface="Arial"/>
+                        </a:rPr>
+                        <a:t>—</a:t>
+                      </a:r>
+                    </a:p>
+                  </a:txBody>
+                  <a:tcPr marL="91440" marR="91440" marT="45720" marB="45720">
+                    <a:lnB w="6350" cap="flat" cmpd="sng" algn="ctr">
+                      <a:solidFill>
+                        <a:srgbClr val="C8CDD3"/>
+                      </a:solidFill>
+                    </a:lnB>
+                    <a:lnT w="6350" cap="flat" cmpd="sng" algn="ctr">
+                      <a:solidFill>
+                        <a:srgbClr val="C8CDD3"/>
+                      </a:solidFill>
+                    </a:lnT>
+                    <a:lnR w="6350" cap="flat" cmpd="sng" algn="ctr">
+                      <a:solidFill>
+                        <a:srgbClr val="C8CDD3"/>
+                      </a:solidFill>
+                    </a:lnR>
+                    <a:lnL w="6350" cap="flat" cmpd="sng" algn="ctr">
+                      <a:solidFill>
+                        <a:srgbClr val="C8CDD3"/>
+                      </a:solidFill>
+                    </a:lnL>
+                    <a:solidFill>
+                      <a:srgbClr val="FFFFFF"/>
+                    </a:solidFill>
+                  </a:tcPr>
+                </a:tc>
+                <a:tc>
+                  <a:txBody>
+                    <a:bodyPr/>
+                    <a:lstStyle/>
+                    <a:p>
+                      <a:r>
+                        <a:rPr sz="800" b="0" i="0">
+                          <a:solidFill>
+                            <a:srgbClr val="1F2937"/>
+                          </a:solidFill>
+                          <a:latin typeface="Arial"/>
+                        </a:rPr>
+                        <a:t>LOC-01 cabled</a:t>
+                      </a:r>
+                    </a:p>
+                  </a:txBody>
+                  <a:tcPr marL="91440" marR="91440" marT="45720" marB="45720">
+                    <a:lnB w="6350" cap="flat" cmpd="sng" algn="ctr">
+                      <a:solidFill>
+                        <a:srgbClr val="C8CDD3"/>
+                      </a:solidFill>
+                    </a:lnB>
+                    <a:lnT w="6350" cap="flat" cmpd="sng" algn="ctr">
+                      <a:solidFill>
+                        <a:srgbClr val="C8CDD3"/>
+                      </a:solidFill>
+                    </a:lnT>
+                    <a:lnR w="6350" cap="flat" cmpd="sng" algn="ctr">
+                      <a:solidFill>
+                        <a:srgbClr val="C8CDD3"/>
+                      </a:solidFill>
+                    </a:lnR>
+                    <a:lnL w="6350" cap="flat" cmpd="sng" algn="ctr">
+                      <a:solidFill>
+                        <a:srgbClr val="C8CDD3"/>
+                      </a:solidFill>
+                    </a:lnL>
+                    <a:solidFill>
+                      <a:srgbClr val="FFFFFF"/>
+                    </a:solidFill>
+                  </a:tcPr>
+                </a:tc>
+              </a:tr>
+              <a:tr h="241442">
+                <a:tc>
+                  <a:txBody>
+                    <a:bodyPr/>
+                    <a:lstStyle/>
+                    <a:p>
+                      <a:r>
+                        <a:rPr sz="800" b="1" i="0">
+                          <a:solidFill>
+                            <a:srgbClr val="1F2937"/>
+                          </a:solidFill>
+                          <a:latin typeface="Arial"/>
+                        </a:rPr>
+                        <a:t>3</a:t>
+                      </a:r>
+                    </a:p>
+                  </a:txBody>
+                  <a:tcPr marL="91440" marR="91440" marT="45720" marB="45720">
+                    <a:lnB w="6350" cap="flat" cmpd="sng" algn="ctr">
+                      <a:solidFill>
+                        <a:srgbClr val="C8CDD3"/>
+                      </a:solidFill>
+                    </a:lnB>
+                    <a:lnT w="6350" cap="flat" cmpd="sng" algn="ctr">
+                      <a:solidFill>
+                        <a:srgbClr val="C8CDD3"/>
+                      </a:solidFill>
+                    </a:lnT>
+                    <a:lnR w="6350" cap="flat" cmpd="sng" algn="ctr">
+                      <a:solidFill>
+                        <a:srgbClr val="C8CDD3"/>
+                      </a:solidFill>
+                    </a:lnR>
+                    <a:lnL w="6350" cap="flat" cmpd="sng" algn="ctr">
+                      <a:solidFill>
+                        <a:srgbClr val="C8CDD3"/>
+                      </a:solidFill>
+                    </a:lnL>
+                    <a:solidFill>
+                      <a:srgbClr val="FFFFFF"/>
+                    </a:solidFill>
+                  </a:tcPr>
+                </a:tc>
+                <a:tc>
+                  <a:txBody>
+                    <a:bodyPr/>
+                    <a:lstStyle/>
+                    <a:p>
+                      <a:r>
+                        <a:rPr sz="800" b="0" i="0">
+                          <a:solidFill>
+                            <a:srgbClr val="1F2937"/>
+                          </a:solidFill>
+                          <a:latin typeface="Arial"/>
+                        </a:rPr>
+                        <a:t>Termination, insulation resistance and continuity testing</a:t>
+                      </a:r>
+                    </a:p>
+                  </a:txBody>
+                  <a:tcPr marL="91440" marR="91440" marT="45720" marB="45720">
+                    <a:lnB w="6350" cap="flat" cmpd="sng" algn="ctr">
+                      <a:solidFill>
+                        <a:srgbClr val="C8CDD3"/>
+                      </a:solidFill>
+                    </a:lnB>
+                    <a:lnT w="6350" cap="flat" cmpd="sng" algn="ctr">
+                      <a:solidFill>
+                        <a:srgbClr val="C8CDD3"/>
+                      </a:solidFill>
+                    </a:lnT>
+                    <a:lnR w="6350" cap="flat" cmpd="sng" algn="ctr">
+                      <a:solidFill>
+                        <a:srgbClr val="C8CDD3"/>
+                      </a:solidFill>
+                    </a:lnR>
+                    <a:lnL w="6350" cap="flat" cmpd="sng" algn="ctr">
+                      <a:solidFill>
+                        <a:srgbClr val="C8CDD3"/>
+                      </a:solidFill>
+                    </a:lnL>
+                    <a:solidFill>
+                      <a:srgbClr val="FFFFFF"/>
+                    </a:solidFill>
+                  </a:tcPr>
+                </a:tc>
+                <a:tc>
+                  <a:txBody>
+                    <a:bodyPr/>
+                    <a:lstStyle/>
+                    <a:p>
+                      <a:r>
+                        <a:rPr sz="800" b="0" i="0">
+                          <a:solidFill>
+                            <a:srgbClr val="1F2937"/>
+                          </a:solidFill>
+                          <a:latin typeface="Arial"/>
+                        </a:rPr>
+                        <a:t>LOC-01 · 1001</a:t>
+                      </a:r>
+                    </a:p>
+                  </a:txBody>
+                  <a:tcPr marL="91440" marR="91440" marT="45720" marB="45720">
+                    <a:lnB w="6350" cap="flat" cmpd="sng" algn="ctr">
+                      <a:solidFill>
+                        <a:srgbClr val="C8CDD3"/>
+                      </a:solidFill>
+                    </a:lnB>
+                    <a:lnT w="6350" cap="flat" cmpd="sng" algn="ctr">
+                      <a:solidFill>
+                        <a:srgbClr val="C8CDD3"/>
+                      </a:solidFill>
+                    </a:lnT>
+                    <a:lnR w="6350" cap="flat" cmpd="sng" algn="ctr">
+                      <a:solidFill>
+                        <a:srgbClr val="C8CDD3"/>
+                      </a:solidFill>
+                    </a:lnR>
+                    <a:lnL w="6350" cap="flat" cmpd="sng" algn="ctr">
+                      <a:solidFill>
+                        <a:srgbClr val="C8CDD3"/>
+                      </a:solidFill>
+                    </a:lnL>
+                    <a:solidFill>
+                      <a:srgbClr val="FFFFFF"/>
+                    </a:solidFill>
+                  </a:tcPr>
+                </a:tc>
+                <a:tc>
+                  <a:txBody>
+                    <a:bodyPr/>
+                    <a:lstStyle/>
+                    <a:p>
+                      <a:r>
+                        <a:rPr sz="800" b="0" i="0">
+                          <a:solidFill>
+                            <a:srgbClr val="1F2937"/>
+                          </a:solidFill>
+                          <a:latin typeface="Arial"/>
+                        </a:rPr>
+                        <a:t>11 No. fittings</a:t>
+                      </a:r>
+                    </a:p>
+                  </a:txBody>
+                  <a:tcPr marL="91440" marR="91440" marT="45720" marB="45720">
+                    <a:lnB w="6350" cap="flat" cmpd="sng" algn="ctr">
+                      <a:solidFill>
+                        <a:srgbClr val="C8CDD3"/>
+                      </a:solidFill>
+                    </a:lnB>
+                    <a:lnT w="6350" cap="flat" cmpd="sng" algn="ctr">
+                      <a:solidFill>
+                        <a:srgbClr val="C8CDD3"/>
+                      </a:solidFill>
+                    </a:lnT>
+                    <a:lnR w="6350" cap="flat" cmpd="sng" algn="ctr">
+                      <a:solidFill>
+                        <a:srgbClr val="C8CDD3"/>
+                      </a:solidFill>
+                    </a:lnR>
+                    <a:lnL w="6350" cap="flat" cmpd="sng" algn="ctr">
+                      <a:solidFill>
+                        <a:srgbClr val="C8CDD3"/>
+                      </a:solidFill>
+                    </a:lnL>
+                    <a:solidFill>
+                      <a:srgbClr val="FFFFFF"/>
+                    </a:solidFill>
+                  </a:tcPr>
+                </a:tc>
+                <a:tc>
+                  <a:txBody>
+                    <a:bodyPr/>
+                    <a:lstStyle/>
+                    <a:p>
+                      <a:r>
+                        <a:rPr sz="800" b="0" i="0">
+                          <a:solidFill>
+                            <a:srgbClr val="1F2937"/>
+                          </a:solidFill>
+                          <a:latin typeface="Arial"/>
+                        </a:rPr>
+                        <a:t>—</a:t>
+                      </a:r>
+                    </a:p>
+                  </a:txBody>
+                  <a:tcPr marL="91440" marR="91440" marT="45720" marB="45720">
+                    <a:lnB w="6350" cap="flat" cmpd="sng" algn="ctr">
+                      <a:solidFill>
+                        <a:srgbClr val="C8CDD3"/>
+                      </a:solidFill>
+                    </a:lnB>
+                    <a:lnT w="6350" cap="flat" cmpd="sng" algn="ctr">
+                      <a:solidFill>
+                        <a:srgbClr val="C8CDD3"/>
+                      </a:solidFill>
+                    </a:lnT>
+                    <a:lnR w="6350" cap="flat" cmpd="sng" algn="ctr">
+                      <a:solidFill>
+                        <a:srgbClr val="C8CDD3"/>
+                      </a:solidFill>
+                    </a:lnR>
+                    <a:lnL w="6350" cap="flat" cmpd="sng" algn="ctr">
+                      <a:solidFill>
+                        <a:srgbClr val="C8CDD3"/>
+                      </a:solidFill>
+                    </a:lnL>
+                    <a:solidFill>
+                      <a:srgbClr val="FFFFFF"/>
+                    </a:solidFill>
+                  </a:tcPr>
+                </a:tc>
+                <a:tc>
+                  <a:txBody>
+                    <a:bodyPr/>
+                    <a:lstStyle/>
+                    <a:p>
+                      <a:r>
+                        <a:rPr sz="800" b="0" i="0">
+                          <a:solidFill>
+                            <a:srgbClr val="1F2937"/>
+                          </a:solidFill>
+                          <a:latin typeface="Arial"/>
+                        </a:rPr>
+                        <a:t>LOC-01 test records issued</a:t>
+                      </a:r>
+                    </a:p>
+                  </a:txBody>
+                  <a:tcPr marL="91440" marR="91440" marT="45720" marB="45720">
+                    <a:lnB w="6350" cap="flat" cmpd="sng" algn="ctr">
+                      <a:solidFill>
+                        <a:srgbClr val="C8CDD3"/>
+                      </a:solidFill>
+                    </a:lnB>
+                    <a:lnT w="6350" cap="flat" cmpd="sng" algn="ctr">
+                      <a:solidFill>
+                        <a:srgbClr val="C8CDD3"/>
+                      </a:solidFill>
+                    </a:lnT>
+                    <a:lnR w="6350" cap="flat" cmpd="sng" algn="ctr">
+                      <a:solidFill>
+                        <a:srgbClr val="C8CDD3"/>
+                      </a:solidFill>
+                    </a:lnR>
+                    <a:lnL w="6350" cap="flat" cmpd="sng" algn="ctr">
+                      <a:solidFill>
+                        <a:srgbClr val="C8CDD3"/>
+                      </a:solidFill>
+                    </a:lnL>
+                    <a:solidFill>
+                      <a:srgbClr val="FFFFFF"/>
+                    </a:solidFill>
+                  </a:tcPr>
+                </a:tc>
+              </a:tr>
+              <a:tr h="241442">
+                <a:tc>
+                  <a:txBody>
+                    <a:bodyPr/>
+                    <a:lstStyle/>
+                    <a:p>
+                      <a:r>
+                        <a:rPr sz="800" b="1" i="0">
+                          <a:solidFill>
+                            <a:srgbClr val="1F2937"/>
+                          </a:solidFill>
+                          <a:latin typeface="Arial"/>
+                        </a:rPr>
+                        <a:t>3</a:t>
+                      </a:r>
+                    </a:p>
+                  </a:txBody>
+                  <a:tcPr marL="91440" marR="91440" marT="45720" marB="45720">
+                    <a:lnB w="6350" cap="flat" cmpd="sng" algn="ctr">
+                      <a:solidFill>
+                        <a:srgbClr val="C8CDD3"/>
+                      </a:solidFill>
+                    </a:lnB>
+                    <a:lnT w="6350" cap="flat" cmpd="sng" algn="ctr">
+                      <a:solidFill>
+                        <a:srgbClr val="C8CDD3"/>
+                      </a:solidFill>
+                    </a:lnT>
+                    <a:lnR w="6350" cap="flat" cmpd="sng" algn="ctr">
+                      <a:solidFill>
+                        <a:srgbClr val="C8CDD3"/>
+                      </a:solidFill>
+                    </a:lnR>
+                    <a:lnL w="6350" cap="flat" cmpd="sng" algn="ctr">
+                      <a:solidFill>
+                        <a:srgbClr val="C8CDD3"/>
+                      </a:solidFill>
+                    </a:lnL>
+                    <a:solidFill>
+                      <a:srgbClr val="FFFFFF"/>
+                    </a:solidFill>
+                  </a:tcPr>
+                </a:tc>
+                <a:tc>
+                  <a:txBody>
+                    <a:bodyPr/>
+                    <a:lstStyle/>
+                    <a:p>
+                      <a:r>
+                        <a:rPr sz="800" b="0" i="0">
+                          <a:solidFill>
+                            <a:srgbClr val="1F2937"/>
+                          </a:solidFill>
+                          <a:latin typeface="Arial"/>
+                        </a:rPr>
+                        <a:t>Backfill, sealant and pavement reinstatement of the saw cut</a:t>
+                      </a:r>
+                    </a:p>
+                  </a:txBody>
+                  <a:tcPr marL="91440" marR="91440" marT="45720" marB="45720">
+                    <a:lnB w="6350" cap="flat" cmpd="sng" algn="ctr">
+                      <a:solidFill>
+                        <a:srgbClr val="C8CDD3"/>
+                      </a:solidFill>
+                    </a:lnB>
+                    <a:lnT w="6350" cap="flat" cmpd="sng" algn="ctr">
+                      <a:solidFill>
+                        <a:srgbClr val="C8CDD3"/>
+                      </a:solidFill>
+                    </a:lnT>
+                    <a:lnR w="6350" cap="flat" cmpd="sng" algn="ctr">
+                      <a:solidFill>
+                        <a:srgbClr val="C8CDD3"/>
+                      </a:solidFill>
+                    </a:lnR>
+                    <a:lnL w="6350" cap="flat" cmpd="sng" algn="ctr">
+                      <a:solidFill>
+                        <a:srgbClr val="C8CDD3"/>
+                      </a:solidFill>
+                    </a:lnL>
+                    <a:solidFill>
+                      <a:srgbClr val="FFFFFF"/>
+                    </a:solidFill>
+                  </a:tcPr>
+                </a:tc>
+                <a:tc>
+                  <a:txBody>
+                    <a:bodyPr/>
+                    <a:lstStyle/>
+                    <a:p>
+                      <a:r>
+                        <a:rPr sz="800" b="0" i="0">
+                          <a:solidFill>
+                            <a:srgbClr val="1F2937"/>
+                          </a:solidFill>
+                          <a:latin typeface="Arial"/>
+                        </a:rPr>
+                        <a:t>LOC-01 · 1001</a:t>
+                      </a:r>
+                    </a:p>
+                  </a:txBody>
+                  <a:tcPr marL="91440" marR="91440" marT="45720" marB="45720">
+                    <a:lnB w="6350" cap="flat" cmpd="sng" algn="ctr">
+                      <a:solidFill>
+                        <a:srgbClr val="C8CDD3"/>
+                      </a:solidFill>
+                    </a:lnB>
+                    <a:lnT w="6350" cap="flat" cmpd="sng" algn="ctr">
+                      <a:solidFill>
+                        <a:srgbClr val="C8CDD3"/>
+                      </a:solidFill>
+                    </a:lnT>
+                    <a:lnR w="6350" cap="flat" cmpd="sng" algn="ctr">
+                      <a:solidFill>
+                        <a:srgbClr val="C8CDD3"/>
+                      </a:solidFill>
+                    </a:lnR>
+                    <a:lnL w="6350" cap="flat" cmpd="sng" algn="ctr">
+                      <a:solidFill>
+                        <a:srgbClr val="C8CDD3"/>
+                      </a:solidFill>
+                    </a:lnL>
+                    <a:solidFill>
+                      <a:srgbClr val="FFFFFF"/>
+                    </a:solidFill>
+                  </a:tcPr>
+                </a:tc>
+                <a:tc>
+                  <a:txBody>
+                    <a:bodyPr/>
+                    <a:lstStyle/>
+                    <a:p>
+                      <a:r>
+                        <a:rPr sz="800" b="0" i="0">
+                          <a:solidFill>
+                            <a:srgbClr val="1F2937"/>
+                          </a:solidFill>
+                          <a:latin typeface="Arial"/>
+                        </a:rPr>
+                        <a:t>approx. 300 m</a:t>
+                      </a:r>
+                    </a:p>
+                  </a:txBody>
+                  <a:tcPr marL="91440" marR="91440" marT="45720" marB="45720">
+                    <a:lnB w="6350" cap="flat" cmpd="sng" algn="ctr">
+                      <a:solidFill>
+                        <a:srgbClr val="C8CDD3"/>
+                      </a:solidFill>
+                    </a:lnB>
+                    <a:lnT w="6350" cap="flat" cmpd="sng" algn="ctr">
+                      <a:solidFill>
+                        <a:srgbClr val="C8CDD3"/>
+                      </a:solidFill>
+                    </a:lnT>
+                    <a:lnR w="6350" cap="flat" cmpd="sng" algn="ctr">
+                      <a:solidFill>
+                        <a:srgbClr val="C8CDD3"/>
+                      </a:solidFill>
+                    </a:lnR>
+                    <a:lnL w="6350" cap="flat" cmpd="sng" algn="ctr">
+                      <a:solidFill>
+                        <a:srgbClr val="C8CDD3"/>
+                      </a:solidFill>
+                    </a:lnL>
+                    <a:solidFill>
+                      <a:srgbClr val="FFFFFF"/>
+                    </a:solidFill>
+                  </a:tcPr>
+                </a:tc>
+                <a:tc>
+                  <a:txBody>
+                    <a:bodyPr/>
+                    <a:lstStyle/>
+                    <a:p>
+                      <a:r>
+                        <a:rPr sz="800" b="0" i="0">
+                          <a:solidFill>
+                            <a:srgbClr val="1F2937"/>
+                          </a:solidFill>
+                          <a:latin typeface="Arial"/>
+                        </a:rPr>
+                        <a:t>Per the awaited detail</a:t>
+                      </a:r>
+                    </a:p>
+                  </a:txBody>
+                  <a:tcPr marL="91440" marR="91440" marT="45720" marB="45720">
+                    <a:lnB w="6350" cap="flat" cmpd="sng" algn="ctr">
+                      <a:solidFill>
+                        <a:srgbClr val="C8CDD3"/>
+                      </a:solidFill>
+                    </a:lnB>
+                    <a:lnT w="6350" cap="flat" cmpd="sng" algn="ctr">
+                      <a:solidFill>
+                        <a:srgbClr val="C8CDD3"/>
+                      </a:solidFill>
+                    </a:lnT>
+                    <a:lnR w="6350" cap="flat" cmpd="sng" algn="ctr">
+                      <a:solidFill>
+                        <a:srgbClr val="C8CDD3"/>
+                      </a:solidFill>
+                    </a:lnR>
+                    <a:lnL w="6350" cap="flat" cmpd="sng" algn="ctr">
+                      <a:solidFill>
+                        <a:srgbClr val="C8CDD3"/>
+                      </a:solidFill>
+                    </a:lnL>
+                    <a:solidFill>
+                      <a:srgbClr val="FFFFFF"/>
+                    </a:solidFill>
+                  </a:tcPr>
+                </a:tc>
+                <a:tc>
+                  <a:txBody>
+                    <a:bodyPr/>
+                    <a:lstStyle/>
+                    <a:p>
+                      <a:r>
+                        <a:rPr sz="800" b="0" i="0">
+                          <a:solidFill>
+                            <a:srgbClr val="1F2937"/>
+                          </a:solidFill>
+                          <a:latin typeface="Arial"/>
+                        </a:rPr>
+                        <a:t>LOC-01 cut sealed; cure period started</a:t>
+                      </a:r>
+                    </a:p>
+                  </a:txBody>
+                  <a:tcPr marL="91440" marR="91440" marT="45720" marB="45720">
+                    <a:lnB w="6350" cap="flat" cmpd="sng" algn="ctr">
+                      <a:solidFill>
+                        <a:srgbClr val="C8CDD3"/>
+                      </a:solidFill>
+                    </a:lnB>
+                    <a:lnT w="6350" cap="flat" cmpd="sng" algn="ctr">
+                      <a:solidFill>
+                        <a:srgbClr val="C8CDD3"/>
+                      </a:solidFill>
+                    </a:lnT>
+                    <a:lnR w="6350" cap="flat" cmpd="sng" algn="ctr">
+                      <a:solidFill>
+                        <a:srgbClr val="C8CDD3"/>
+                      </a:solidFill>
+                    </a:lnR>
+                    <a:lnL w="6350" cap="flat" cmpd="sng" algn="ctr">
+                      <a:solidFill>
+                        <a:srgbClr val="C8CDD3"/>
+                      </a:solidFill>
+                    </a:lnL>
+                    <a:solidFill>
+                      <a:srgbClr val="FFFFFF"/>
+                    </a:solidFill>
+                  </a:tcPr>
+                </a:tc>
+              </a:tr>
+              <a:tr h="241442">
+                <a:tc>
+                  <a:txBody>
+                    <a:bodyPr/>
+                    <a:lstStyle/>
+                    <a:p>
+                      <a:r>
+                        <a:rPr sz="800" b="1" i="0">
+                          <a:solidFill>
+                            <a:srgbClr val="1F2937"/>
+                          </a:solidFill>
+                          <a:latin typeface="Arial"/>
+                        </a:rPr>
+                        <a:t>4</a:t>
+                      </a:r>
+                    </a:p>
+                  </a:txBody>
+                  <a:tcPr marL="91440" marR="91440" marT="45720" marB="45720">
+                    <a:lnB w="6350" cap="flat" cmpd="sng" algn="ctr">
+                      <a:solidFill>
+                        <a:srgbClr val="C8CDD3"/>
+                      </a:solidFill>
+                    </a:lnB>
+                    <a:lnT w="6350" cap="flat" cmpd="sng" algn="ctr">
+                      <a:solidFill>
+                        <a:srgbClr val="C8CDD3"/>
+                      </a:solidFill>
+                    </a:lnT>
+                    <a:lnR w="6350" cap="flat" cmpd="sng" algn="ctr">
+                      <a:solidFill>
+                        <a:srgbClr val="C8CDD3"/>
+                      </a:solidFill>
+                    </a:lnR>
+                    <a:lnL w="6350" cap="flat" cmpd="sng" algn="ctr">
+                      <a:solidFill>
+                        <a:srgbClr val="C8CDD3"/>
+                      </a:solidFill>
+                    </a:lnL>
+                    <a:solidFill>
+                      <a:srgbClr val="F4F6F8"/>
                     </a:solidFill>
                   </a:tcPr>
                 </a:tc>
@@ -55482,7 +56244,7 @@
                       </a:solidFill>
                     </a:lnL>
                     <a:solidFill>
-                      <a:srgbClr val="FFFFFF"/>
+                      <a:srgbClr val="F4F6F8"/>
                     </a:solidFill>
                   </a:tcPr>
                 </a:tc>
@@ -55498,7 +56260,939 @@
                           </a:solidFill>
                           <a:latin typeface="Arial"/>
                         </a:rPr>
-                        <a:t>LOC-02 / 03</a:t>
+                        <a:t>LOC-03 · 1003</a:t>
+                      </a:r>
+                    </a:p>
+                  </a:txBody>
+                  <a:tcPr marL="91440" marR="91440" marT="45720" marB="45720">
+                    <a:lnB w="6350" cap="flat" cmpd="sng" algn="ctr">
+                      <a:solidFill>
+                        <a:srgbClr val="C8CDD3"/>
+                      </a:solidFill>
+                    </a:lnB>
+                    <a:lnT w="6350" cap="flat" cmpd="sng" algn="ctr">
+                      <a:solidFill>
+                        <a:srgbClr val="C8CDD3"/>
+                      </a:solidFill>
+                    </a:lnT>
+                    <a:lnR w="6350" cap="flat" cmpd="sng" algn="ctr">
+                      <a:solidFill>
+                        <a:srgbClr val="C8CDD3"/>
+                      </a:solidFill>
+                    </a:lnR>
+                    <a:lnL w="6350" cap="flat" cmpd="sng" algn="ctr">
+                      <a:solidFill>
+                        <a:srgbClr val="C8CDD3"/>
+                      </a:solidFill>
+                    </a:lnL>
+                    <a:solidFill>
+                      <a:srgbClr val="F4F6F8"/>
+                    </a:solidFill>
+                  </a:tcPr>
+                </a:tc>
+                <a:tc>
+                  <a:txBody>
+                    <a:bodyPr/>
+                    <a:lstStyle/>
+                    <a:p>
+                      <a:r>
+                        <a:rPr sz="800" b="0" i="0">
+                          <a:solidFill>
+                            <a:srgbClr val="1F2937"/>
+                          </a:solidFill>
+                          <a:latin typeface="Arial"/>
+                        </a:rPr>
+                        <a:t>approx. 95 m</a:t>
+                      </a:r>
+                    </a:p>
+                  </a:txBody>
+                  <a:tcPr marL="91440" marR="91440" marT="45720" marB="45720">
+                    <a:lnB w="6350" cap="flat" cmpd="sng" algn="ctr">
+                      <a:solidFill>
+                        <a:srgbClr val="C8CDD3"/>
+                      </a:solidFill>
+                    </a:lnB>
+                    <a:lnT w="6350" cap="flat" cmpd="sng" algn="ctr">
+                      <a:solidFill>
+                        <a:srgbClr val="C8CDD3"/>
+                      </a:solidFill>
+                    </a:lnT>
+                    <a:lnR w="6350" cap="flat" cmpd="sng" algn="ctr">
+                      <a:solidFill>
+                        <a:srgbClr val="C8CDD3"/>
+                      </a:solidFill>
+                    </a:lnR>
+                    <a:lnL w="6350" cap="flat" cmpd="sng" algn="ctr">
+                      <a:solidFill>
+                        <a:srgbClr val="C8CDD3"/>
+                      </a:solidFill>
+                    </a:lnL>
+                    <a:solidFill>
+                      <a:srgbClr val="F4F6F8"/>
+                    </a:solidFill>
+                  </a:tcPr>
+                </a:tc>
+                <a:tc>
+                  <a:txBody>
+                    <a:bodyPr/>
+                    <a:lstStyle/>
+                    <a:p>
+                      <a:r>
+                        <a:rPr sz="800" b="0" i="0">
+                          <a:solidFill>
+                            <a:srgbClr val="1F2937"/>
+                          </a:solidFill>
+                          <a:latin typeface="Arial"/>
+                        </a:rPr>
+                        <a:t>H5 — detail accepted</a:t>
+                      </a:r>
+                    </a:p>
+                  </a:txBody>
+                  <a:tcPr marL="91440" marR="91440" marT="45720" marB="45720">
+                    <a:lnB w="6350" cap="flat" cmpd="sng" algn="ctr">
+                      <a:solidFill>
+                        <a:srgbClr val="C8CDD3"/>
+                      </a:solidFill>
+                    </a:lnB>
+                    <a:lnT w="6350" cap="flat" cmpd="sng" algn="ctr">
+                      <a:solidFill>
+                        <a:srgbClr val="C8CDD3"/>
+                      </a:solidFill>
+                    </a:lnT>
+                    <a:lnR w="6350" cap="flat" cmpd="sng" algn="ctr">
+                      <a:solidFill>
+                        <a:srgbClr val="C8CDD3"/>
+                      </a:solidFill>
+                    </a:lnR>
+                    <a:lnL w="6350" cap="flat" cmpd="sng" algn="ctr">
+                      <a:solidFill>
+                        <a:srgbClr val="C8CDD3"/>
+                      </a:solidFill>
+                    </a:lnL>
+                    <a:solidFill>
+                      <a:srgbClr val="F4F6F8"/>
+                    </a:solidFill>
+                  </a:tcPr>
+                </a:tc>
+                <a:tc>
+                  <a:txBody>
+                    <a:bodyPr/>
+                    <a:lstStyle/>
+                    <a:p>
+                      <a:r>
+                        <a:rPr sz="800" b="0" i="0">
+                          <a:solidFill>
+                            <a:srgbClr val="1F2937"/>
+                          </a:solidFill>
+                          <a:latin typeface="Arial"/>
+                        </a:rPr>
+                        <a:t>LOC-03 route cut</a:t>
+                      </a:r>
+                    </a:p>
+                  </a:txBody>
+                  <a:tcPr marL="91440" marR="91440" marT="45720" marB="45720">
+                    <a:lnB w="6350" cap="flat" cmpd="sng" algn="ctr">
+                      <a:solidFill>
+                        <a:srgbClr val="C8CDD3"/>
+                      </a:solidFill>
+                    </a:lnB>
+                    <a:lnT w="6350" cap="flat" cmpd="sng" algn="ctr">
+                      <a:solidFill>
+                        <a:srgbClr val="C8CDD3"/>
+                      </a:solidFill>
+                    </a:lnT>
+                    <a:lnR w="6350" cap="flat" cmpd="sng" algn="ctr">
+                      <a:solidFill>
+                        <a:srgbClr val="C8CDD3"/>
+                      </a:solidFill>
+                    </a:lnR>
+                    <a:lnL w="6350" cap="flat" cmpd="sng" algn="ctr">
+                      <a:solidFill>
+                        <a:srgbClr val="C8CDD3"/>
+                      </a:solidFill>
+                    </a:lnL>
+                    <a:solidFill>
+                      <a:srgbClr val="F4F6F8"/>
+                    </a:solidFill>
+                  </a:tcPr>
+                </a:tc>
+              </a:tr>
+              <a:tr h="241442">
+                <a:tc>
+                  <a:txBody>
+                    <a:bodyPr/>
+                    <a:lstStyle/>
+                    <a:p>
+                      <a:r>
+                        <a:rPr sz="800" b="1" i="0">
+                          <a:solidFill>
+                            <a:srgbClr val="1F2937"/>
+                          </a:solidFill>
+                          <a:latin typeface="Arial"/>
+                        </a:rPr>
+                        <a:t>4</a:t>
+                      </a:r>
+                    </a:p>
+                  </a:txBody>
+                  <a:tcPr marL="91440" marR="91440" marT="45720" marB="45720">
+                    <a:lnB w="6350" cap="flat" cmpd="sng" algn="ctr">
+                      <a:solidFill>
+                        <a:srgbClr val="C8CDD3"/>
+                      </a:solidFill>
+                    </a:lnB>
+                    <a:lnT w="6350" cap="flat" cmpd="sng" algn="ctr">
+                      <a:solidFill>
+                        <a:srgbClr val="C8CDD3"/>
+                      </a:solidFill>
+                    </a:lnT>
+                    <a:lnR w="6350" cap="flat" cmpd="sng" algn="ctr">
+                      <a:solidFill>
+                        <a:srgbClr val="C8CDD3"/>
+                      </a:solidFill>
+                    </a:lnR>
+                    <a:lnL w="6350" cap="flat" cmpd="sng" algn="ctr">
+                      <a:solidFill>
+                        <a:srgbClr val="C8CDD3"/>
+                      </a:solidFill>
+                    </a:lnL>
+                    <a:solidFill>
+                      <a:srgbClr val="F4F6F8"/>
+                    </a:solidFill>
+                  </a:tcPr>
+                </a:tc>
+                <a:tc>
+                  <a:txBody>
+                    <a:bodyPr/>
+                    <a:lstStyle/>
+                    <a:p>
+                      <a:r>
+                        <a:rPr sz="800" b="0" i="0">
+                          <a:solidFill>
+                            <a:srgbClr val="1F2937"/>
+                          </a:solidFill>
+                          <a:latin typeface="Arial"/>
+                        </a:rPr>
+                        <a:t>Set 1 No. new base; the balance takes side entry into its existing base</a:t>
+                      </a:r>
+                    </a:p>
+                  </a:txBody>
+                  <a:tcPr marL="91440" marR="91440" marT="45720" marB="45720">
+                    <a:lnB w="6350" cap="flat" cmpd="sng" algn="ctr">
+                      <a:solidFill>
+                        <a:srgbClr val="C8CDD3"/>
+                      </a:solidFill>
+                    </a:lnB>
+                    <a:lnT w="6350" cap="flat" cmpd="sng" algn="ctr">
+                      <a:solidFill>
+                        <a:srgbClr val="C8CDD3"/>
+                      </a:solidFill>
+                    </a:lnT>
+                    <a:lnR w="6350" cap="flat" cmpd="sng" algn="ctr">
+                      <a:solidFill>
+                        <a:srgbClr val="C8CDD3"/>
+                      </a:solidFill>
+                    </a:lnR>
+                    <a:lnL w="6350" cap="flat" cmpd="sng" algn="ctr">
+                      <a:solidFill>
+                        <a:srgbClr val="C8CDD3"/>
+                      </a:solidFill>
+                    </a:lnL>
+                    <a:solidFill>
+                      <a:srgbClr val="F4F6F8"/>
+                    </a:solidFill>
+                  </a:tcPr>
+                </a:tc>
+                <a:tc>
+                  <a:txBody>
+                    <a:bodyPr/>
+                    <a:lstStyle/>
+                    <a:p>
+                      <a:r>
+                        <a:rPr sz="800" b="0" i="0">
+                          <a:solidFill>
+                            <a:srgbClr val="1F2937"/>
+                          </a:solidFill>
+                          <a:latin typeface="Arial"/>
+                        </a:rPr>
+                        <a:t>LOC-03 · 1003</a:t>
+                      </a:r>
+                    </a:p>
+                  </a:txBody>
+                  <a:tcPr marL="91440" marR="91440" marT="45720" marB="45720">
+                    <a:lnB w="6350" cap="flat" cmpd="sng" algn="ctr">
+                      <a:solidFill>
+                        <a:srgbClr val="C8CDD3"/>
+                      </a:solidFill>
+                    </a:lnB>
+                    <a:lnT w="6350" cap="flat" cmpd="sng" algn="ctr">
+                      <a:solidFill>
+                        <a:srgbClr val="C8CDD3"/>
+                      </a:solidFill>
+                    </a:lnT>
+                    <a:lnR w="6350" cap="flat" cmpd="sng" algn="ctr">
+                      <a:solidFill>
+                        <a:srgbClr val="C8CDD3"/>
+                      </a:solidFill>
+                    </a:lnR>
+                    <a:lnL w="6350" cap="flat" cmpd="sng" algn="ctr">
+                      <a:solidFill>
+                        <a:srgbClr val="C8CDD3"/>
+                      </a:solidFill>
+                    </a:lnL>
+                    <a:solidFill>
+                      <a:srgbClr val="F4F6F8"/>
+                    </a:solidFill>
+                  </a:tcPr>
+                </a:tc>
+                <a:tc>
+                  <a:txBody>
+                    <a:bodyPr/>
+                    <a:lstStyle/>
+                    <a:p>
+                      <a:r>
+                        <a:rPr sz="800" b="0" i="0">
+                          <a:solidFill>
+                            <a:srgbClr val="1F2937"/>
+                          </a:solidFill>
+                          <a:latin typeface="Arial"/>
+                        </a:rPr>
+                        <a:t>1 No. 12" + 3 No.</a:t>
+                      </a:r>
+                    </a:p>
+                  </a:txBody>
+                  <a:tcPr marL="91440" marR="91440" marT="45720" marB="45720">
+                    <a:lnB w="6350" cap="flat" cmpd="sng" algn="ctr">
+                      <a:solidFill>
+                        <a:srgbClr val="C8CDD3"/>
+                      </a:solidFill>
+                    </a:lnB>
+                    <a:lnT w="6350" cap="flat" cmpd="sng" algn="ctr">
+                      <a:solidFill>
+                        <a:srgbClr val="C8CDD3"/>
+                      </a:solidFill>
+                    </a:lnT>
+                    <a:lnR w="6350" cap="flat" cmpd="sng" algn="ctr">
+                      <a:solidFill>
+                        <a:srgbClr val="C8CDD3"/>
+                      </a:solidFill>
+                    </a:lnR>
+                    <a:lnL w="6350" cap="flat" cmpd="sng" algn="ctr">
+                      <a:solidFill>
+                        <a:srgbClr val="C8CDD3"/>
+                      </a:solidFill>
+                    </a:lnL>
+                    <a:solidFill>
+                      <a:srgbClr val="F4F6F8"/>
+                    </a:solidFill>
+                  </a:tcPr>
+                </a:tc>
+                <a:tc>
+                  <a:txBody>
+                    <a:bodyPr/>
+                    <a:lstStyle/>
+                    <a:p>
+                      <a:r>
+                        <a:rPr sz="800" b="0" i="0">
+                          <a:solidFill>
+                            <a:srgbClr val="1F2937"/>
+                          </a:solidFill>
+                          <a:latin typeface="Arial"/>
+                        </a:rPr>
+                        <a:t>—</a:t>
+                      </a:r>
+                    </a:p>
+                  </a:txBody>
+                  <a:tcPr marL="91440" marR="91440" marT="45720" marB="45720">
+                    <a:lnB w="6350" cap="flat" cmpd="sng" algn="ctr">
+                      <a:solidFill>
+                        <a:srgbClr val="C8CDD3"/>
+                      </a:solidFill>
+                    </a:lnB>
+                    <a:lnT w="6350" cap="flat" cmpd="sng" algn="ctr">
+                      <a:solidFill>
+                        <a:srgbClr val="C8CDD3"/>
+                      </a:solidFill>
+                    </a:lnT>
+                    <a:lnR w="6350" cap="flat" cmpd="sng" algn="ctr">
+                      <a:solidFill>
+                        <a:srgbClr val="C8CDD3"/>
+                      </a:solidFill>
+                    </a:lnR>
+                    <a:lnL w="6350" cap="flat" cmpd="sng" algn="ctr">
+                      <a:solidFill>
+                        <a:srgbClr val="C8CDD3"/>
+                      </a:solidFill>
+                    </a:lnL>
+                    <a:solidFill>
+                      <a:srgbClr val="F4F6F8"/>
+                    </a:solidFill>
+                  </a:tcPr>
+                </a:tc>
+                <a:tc>
+                  <a:txBody>
+                    <a:bodyPr/>
+                    <a:lstStyle/>
+                    <a:p>
+                      <a:r>
+                        <a:rPr sz="800" b="0" i="0">
+                          <a:solidFill>
+                            <a:srgbClr val="1F2937"/>
+                          </a:solidFill>
+                          <a:latin typeface="Arial"/>
+                        </a:rPr>
+                        <a:t>Bases ready to receive cable</a:t>
+                      </a:r>
+                    </a:p>
+                  </a:txBody>
+                  <a:tcPr marL="91440" marR="91440" marT="45720" marB="45720">
+                    <a:lnB w="6350" cap="flat" cmpd="sng" algn="ctr">
+                      <a:solidFill>
+                        <a:srgbClr val="C8CDD3"/>
+                      </a:solidFill>
+                    </a:lnB>
+                    <a:lnT w="6350" cap="flat" cmpd="sng" algn="ctr">
+                      <a:solidFill>
+                        <a:srgbClr val="C8CDD3"/>
+                      </a:solidFill>
+                    </a:lnT>
+                    <a:lnR w="6350" cap="flat" cmpd="sng" algn="ctr">
+                      <a:solidFill>
+                        <a:srgbClr val="C8CDD3"/>
+                      </a:solidFill>
+                    </a:lnR>
+                    <a:lnL w="6350" cap="flat" cmpd="sng" algn="ctr">
+                      <a:solidFill>
+                        <a:srgbClr val="C8CDD3"/>
+                      </a:solidFill>
+                    </a:lnL>
+                    <a:solidFill>
+                      <a:srgbClr val="F4F6F8"/>
+                    </a:solidFill>
+                  </a:tcPr>
+                </a:tc>
+              </a:tr>
+              <a:tr h="241442">
+                <a:tc>
+                  <a:txBody>
+                    <a:bodyPr/>
+                    <a:lstStyle/>
+                    <a:p>
+                      <a:r>
+                        <a:rPr sz="800" b="1" i="0">
+                          <a:solidFill>
+                            <a:srgbClr val="1F2937"/>
+                          </a:solidFill>
+                          <a:latin typeface="Arial"/>
+                        </a:rPr>
+                        <a:t>4</a:t>
+                      </a:r>
+                    </a:p>
+                  </a:txBody>
+                  <a:tcPr marL="91440" marR="91440" marT="45720" marB="45720">
+                    <a:lnB w="6350" cap="flat" cmpd="sng" algn="ctr">
+                      <a:solidFill>
+                        <a:srgbClr val="C8CDD3"/>
+                      </a:solidFill>
+                    </a:lnB>
+                    <a:lnT w="6350" cap="flat" cmpd="sng" algn="ctr">
+                      <a:solidFill>
+                        <a:srgbClr val="C8CDD3"/>
+                      </a:solidFill>
+                    </a:lnT>
+                    <a:lnR w="6350" cap="flat" cmpd="sng" algn="ctr">
+                      <a:solidFill>
+                        <a:srgbClr val="C8CDD3"/>
+                      </a:solidFill>
+                    </a:lnR>
+                    <a:lnL w="6350" cap="flat" cmpd="sng" algn="ctr">
+                      <a:solidFill>
+                        <a:srgbClr val="C8CDD3"/>
+                      </a:solidFill>
+                    </a:lnL>
+                    <a:solidFill>
+                      <a:srgbClr val="F4F6F8"/>
+                    </a:solidFill>
+                  </a:tcPr>
+                </a:tc>
+                <a:tc>
+                  <a:txBody>
+                    <a:bodyPr/>
+                    <a:lstStyle/>
+                    <a:p>
+                      <a:r>
+                        <a:rPr sz="800" b="0" i="0">
+                          <a:solidFill>
+                            <a:srgbClr val="1F2937"/>
+                          </a:solidFill>
+                          <a:latin typeface="Arial"/>
+                        </a:rPr>
+                        <a:t>Cable, termination, insulation resistance and continuity testing</a:t>
+                      </a:r>
+                    </a:p>
+                  </a:txBody>
+                  <a:tcPr marL="91440" marR="91440" marT="45720" marB="45720">
+                    <a:lnB w="6350" cap="flat" cmpd="sng" algn="ctr">
+                      <a:solidFill>
+                        <a:srgbClr val="C8CDD3"/>
+                      </a:solidFill>
+                    </a:lnB>
+                    <a:lnT w="6350" cap="flat" cmpd="sng" algn="ctr">
+                      <a:solidFill>
+                        <a:srgbClr val="C8CDD3"/>
+                      </a:solidFill>
+                    </a:lnT>
+                    <a:lnR w="6350" cap="flat" cmpd="sng" algn="ctr">
+                      <a:solidFill>
+                        <a:srgbClr val="C8CDD3"/>
+                      </a:solidFill>
+                    </a:lnR>
+                    <a:lnL w="6350" cap="flat" cmpd="sng" algn="ctr">
+                      <a:solidFill>
+                        <a:srgbClr val="C8CDD3"/>
+                      </a:solidFill>
+                    </a:lnL>
+                    <a:solidFill>
+                      <a:srgbClr val="F4F6F8"/>
+                    </a:solidFill>
+                  </a:tcPr>
+                </a:tc>
+                <a:tc>
+                  <a:txBody>
+                    <a:bodyPr/>
+                    <a:lstStyle/>
+                    <a:p>
+                      <a:r>
+                        <a:rPr sz="800" b="0" i="0">
+                          <a:solidFill>
+                            <a:srgbClr val="1F2937"/>
+                          </a:solidFill>
+                          <a:latin typeface="Arial"/>
+                        </a:rPr>
+                        <a:t>LOC-03 · 1003</a:t>
+                      </a:r>
+                    </a:p>
+                  </a:txBody>
+                  <a:tcPr marL="91440" marR="91440" marT="45720" marB="45720">
+                    <a:lnB w="6350" cap="flat" cmpd="sng" algn="ctr">
+                      <a:solidFill>
+                        <a:srgbClr val="C8CDD3"/>
+                      </a:solidFill>
+                    </a:lnB>
+                    <a:lnT w="6350" cap="flat" cmpd="sng" algn="ctr">
+                      <a:solidFill>
+                        <a:srgbClr val="C8CDD3"/>
+                      </a:solidFill>
+                    </a:lnT>
+                    <a:lnR w="6350" cap="flat" cmpd="sng" algn="ctr">
+                      <a:solidFill>
+                        <a:srgbClr val="C8CDD3"/>
+                      </a:solidFill>
+                    </a:lnR>
+                    <a:lnL w="6350" cap="flat" cmpd="sng" algn="ctr">
+                      <a:solidFill>
+                        <a:srgbClr val="C8CDD3"/>
+                      </a:solidFill>
+                    </a:lnL>
+                    <a:solidFill>
+                      <a:srgbClr val="F4F6F8"/>
+                    </a:solidFill>
+                  </a:tcPr>
+                </a:tc>
+                <a:tc>
+                  <a:txBody>
+                    <a:bodyPr/>
+                    <a:lstStyle/>
+                    <a:p>
+                      <a:r>
+                        <a:rPr sz="800" b="0" i="0">
+                          <a:solidFill>
+                            <a:srgbClr val="1F2937"/>
+                          </a:solidFill>
+                          <a:latin typeface="Arial"/>
+                        </a:rPr>
+                        <a:t>4 No. runs</a:t>
+                      </a:r>
+                    </a:p>
+                  </a:txBody>
+                  <a:tcPr marL="91440" marR="91440" marT="45720" marB="45720">
+                    <a:lnB w="6350" cap="flat" cmpd="sng" algn="ctr">
+                      <a:solidFill>
+                        <a:srgbClr val="C8CDD3"/>
+                      </a:solidFill>
+                    </a:lnB>
+                    <a:lnT w="6350" cap="flat" cmpd="sng" algn="ctr">
+                      <a:solidFill>
+                        <a:srgbClr val="C8CDD3"/>
+                      </a:solidFill>
+                    </a:lnT>
+                    <a:lnR w="6350" cap="flat" cmpd="sng" algn="ctr">
+                      <a:solidFill>
+                        <a:srgbClr val="C8CDD3"/>
+                      </a:solidFill>
+                    </a:lnR>
+                    <a:lnL w="6350" cap="flat" cmpd="sng" algn="ctr">
+                      <a:solidFill>
+                        <a:srgbClr val="C8CDD3"/>
+                      </a:solidFill>
+                    </a:lnL>
+                    <a:solidFill>
+                      <a:srgbClr val="F4F6F8"/>
+                    </a:solidFill>
+                  </a:tcPr>
+                </a:tc>
+                <a:tc>
+                  <a:txBody>
+                    <a:bodyPr/>
+                    <a:lstStyle/>
+                    <a:p>
+                      <a:r>
+                        <a:rPr sz="800" b="0" i="0">
+                          <a:solidFill>
+                            <a:srgbClr val="1F2937"/>
+                          </a:solidFill>
+                          <a:latin typeface="Arial"/>
+                        </a:rPr>
+                        <a:t>—</a:t>
+                      </a:r>
+                    </a:p>
+                  </a:txBody>
+                  <a:tcPr marL="91440" marR="91440" marT="45720" marB="45720">
+                    <a:lnB w="6350" cap="flat" cmpd="sng" algn="ctr">
+                      <a:solidFill>
+                        <a:srgbClr val="C8CDD3"/>
+                      </a:solidFill>
+                    </a:lnB>
+                    <a:lnT w="6350" cap="flat" cmpd="sng" algn="ctr">
+                      <a:solidFill>
+                        <a:srgbClr val="C8CDD3"/>
+                      </a:solidFill>
+                    </a:lnT>
+                    <a:lnR w="6350" cap="flat" cmpd="sng" algn="ctr">
+                      <a:solidFill>
+                        <a:srgbClr val="C8CDD3"/>
+                      </a:solidFill>
+                    </a:lnR>
+                    <a:lnL w="6350" cap="flat" cmpd="sng" algn="ctr">
+                      <a:solidFill>
+                        <a:srgbClr val="C8CDD3"/>
+                      </a:solidFill>
+                    </a:lnL>
+                    <a:solidFill>
+                      <a:srgbClr val="F4F6F8"/>
+                    </a:solidFill>
+                  </a:tcPr>
+                </a:tc>
+                <a:tc>
+                  <a:txBody>
+                    <a:bodyPr/>
+                    <a:lstStyle/>
+                    <a:p>
+                      <a:r>
+                        <a:rPr sz="800" b="0" i="0">
+                          <a:solidFill>
+                            <a:srgbClr val="1F2937"/>
+                          </a:solidFill>
+                          <a:latin typeface="Arial"/>
+                        </a:rPr>
+                        <a:t>LOC-03 test records issued</a:t>
+                      </a:r>
+                    </a:p>
+                  </a:txBody>
+                  <a:tcPr marL="91440" marR="91440" marT="45720" marB="45720">
+                    <a:lnB w="6350" cap="flat" cmpd="sng" algn="ctr">
+                      <a:solidFill>
+                        <a:srgbClr val="C8CDD3"/>
+                      </a:solidFill>
+                    </a:lnB>
+                    <a:lnT w="6350" cap="flat" cmpd="sng" algn="ctr">
+                      <a:solidFill>
+                        <a:srgbClr val="C8CDD3"/>
+                      </a:solidFill>
+                    </a:lnT>
+                    <a:lnR w="6350" cap="flat" cmpd="sng" algn="ctr">
+                      <a:solidFill>
+                        <a:srgbClr val="C8CDD3"/>
+                      </a:solidFill>
+                    </a:lnR>
+                    <a:lnL w="6350" cap="flat" cmpd="sng" algn="ctr">
+                      <a:solidFill>
+                        <a:srgbClr val="C8CDD3"/>
+                      </a:solidFill>
+                    </a:lnL>
+                    <a:solidFill>
+                      <a:srgbClr val="F4F6F8"/>
+                    </a:solidFill>
+                  </a:tcPr>
+                </a:tc>
+              </a:tr>
+              <a:tr h="241442">
+                <a:tc>
+                  <a:txBody>
+                    <a:bodyPr/>
+                    <a:lstStyle/>
+                    <a:p>
+                      <a:r>
+                        <a:rPr sz="800" b="1" i="0">
+                          <a:solidFill>
+                            <a:srgbClr val="1F2937"/>
+                          </a:solidFill>
+                          <a:latin typeface="Arial"/>
+                        </a:rPr>
+                        <a:t>4</a:t>
+                      </a:r>
+                    </a:p>
+                  </a:txBody>
+                  <a:tcPr marL="91440" marR="91440" marT="45720" marB="45720">
+                    <a:lnB w="6350" cap="flat" cmpd="sng" algn="ctr">
+                      <a:solidFill>
+                        <a:srgbClr val="C8CDD3"/>
+                      </a:solidFill>
+                    </a:lnB>
+                    <a:lnT w="6350" cap="flat" cmpd="sng" algn="ctr">
+                      <a:solidFill>
+                        <a:srgbClr val="C8CDD3"/>
+                      </a:solidFill>
+                    </a:lnT>
+                    <a:lnR w="6350" cap="flat" cmpd="sng" algn="ctr">
+                      <a:solidFill>
+                        <a:srgbClr val="C8CDD3"/>
+                      </a:solidFill>
+                    </a:lnR>
+                    <a:lnL w="6350" cap="flat" cmpd="sng" algn="ctr">
+                      <a:solidFill>
+                        <a:srgbClr val="C8CDD3"/>
+                      </a:solidFill>
+                    </a:lnL>
+                    <a:solidFill>
+                      <a:srgbClr val="F4F6F8"/>
+                    </a:solidFill>
+                  </a:tcPr>
+                </a:tc>
+                <a:tc>
+                  <a:txBody>
+                    <a:bodyPr/>
+                    <a:lstStyle/>
+                    <a:p>
+                      <a:r>
+                        <a:rPr sz="800" b="0" i="0">
+                          <a:solidFill>
+                            <a:srgbClr val="1F2937"/>
+                          </a:solidFill>
+                          <a:latin typeface="Arial"/>
+                        </a:rPr>
+                        <a:t>Reinstatement of the cut; re-fix RRM.557 and RRM.670</a:t>
+                      </a:r>
+                    </a:p>
+                  </a:txBody>
+                  <a:tcPr marL="91440" marR="91440" marT="45720" marB="45720">
+                    <a:lnB w="6350" cap="flat" cmpd="sng" algn="ctr">
+                      <a:solidFill>
+                        <a:srgbClr val="C8CDD3"/>
+                      </a:solidFill>
+                    </a:lnB>
+                    <a:lnT w="6350" cap="flat" cmpd="sng" algn="ctr">
+                      <a:solidFill>
+                        <a:srgbClr val="C8CDD3"/>
+                      </a:solidFill>
+                    </a:lnT>
+                    <a:lnR w="6350" cap="flat" cmpd="sng" algn="ctr">
+                      <a:solidFill>
+                        <a:srgbClr val="C8CDD3"/>
+                      </a:solidFill>
+                    </a:lnR>
+                    <a:lnL w="6350" cap="flat" cmpd="sng" algn="ctr">
+                      <a:solidFill>
+                        <a:srgbClr val="C8CDD3"/>
+                      </a:solidFill>
+                    </a:lnL>
+                    <a:solidFill>
+                      <a:srgbClr val="F4F6F8"/>
+                    </a:solidFill>
+                  </a:tcPr>
+                </a:tc>
+                <a:tc>
+                  <a:txBody>
+                    <a:bodyPr/>
+                    <a:lstStyle/>
+                    <a:p>
+                      <a:r>
+                        <a:rPr sz="800" b="0" i="0">
+                          <a:solidFill>
+                            <a:srgbClr val="1F2937"/>
+                          </a:solidFill>
+                          <a:latin typeface="Arial"/>
+                        </a:rPr>
+                        <a:t>LOC-03 · 1003</a:t>
+                      </a:r>
+                    </a:p>
+                  </a:txBody>
+                  <a:tcPr marL="91440" marR="91440" marT="45720" marB="45720">
+                    <a:lnB w="6350" cap="flat" cmpd="sng" algn="ctr">
+                      <a:solidFill>
+                        <a:srgbClr val="C8CDD3"/>
+                      </a:solidFill>
+                    </a:lnB>
+                    <a:lnT w="6350" cap="flat" cmpd="sng" algn="ctr">
+                      <a:solidFill>
+                        <a:srgbClr val="C8CDD3"/>
+                      </a:solidFill>
+                    </a:lnT>
+                    <a:lnR w="6350" cap="flat" cmpd="sng" algn="ctr">
+                      <a:solidFill>
+                        <a:srgbClr val="C8CDD3"/>
+                      </a:solidFill>
+                    </a:lnR>
+                    <a:lnL w="6350" cap="flat" cmpd="sng" algn="ctr">
+                      <a:solidFill>
+                        <a:srgbClr val="C8CDD3"/>
+                      </a:solidFill>
+                    </a:lnL>
+                    <a:solidFill>
+                      <a:srgbClr val="F4F6F8"/>
+                    </a:solidFill>
+                  </a:tcPr>
+                </a:tc>
+                <a:tc>
+                  <a:txBody>
+                    <a:bodyPr/>
+                    <a:lstStyle/>
+                    <a:p>
+                      <a:r>
+                        <a:rPr sz="800" b="0" i="0">
+                          <a:solidFill>
+                            <a:srgbClr val="1F2937"/>
+                          </a:solidFill>
+                          <a:latin typeface="Arial"/>
+                        </a:rPr>
+                        <a:t>approx. 95 m · 2 No. RRM</a:t>
+                      </a:r>
+                    </a:p>
+                  </a:txBody>
+                  <a:tcPr marL="91440" marR="91440" marT="45720" marB="45720">
+                    <a:lnB w="6350" cap="flat" cmpd="sng" algn="ctr">
+                      <a:solidFill>
+                        <a:srgbClr val="C8CDD3"/>
+                      </a:solidFill>
+                    </a:lnB>
+                    <a:lnT w="6350" cap="flat" cmpd="sng" algn="ctr">
+                      <a:solidFill>
+                        <a:srgbClr val="C8CDD3"/>
+                      </a:solidFill>
+                    </a:lnT>
+                    <a:lnR w="6350" cap="flat" cmpd="sng" algn="ctr">
+                      <a:solidFill>
+                        <a:srgbClr val="C8CDD3"/>
+                      </a:solidFill>
+                    </a:lnR>
+                    <a:lnL w="6350" cap="flat" cmpd="sng" algn="ctr">
+                      <a:solidFill>
+                        <a:srgbClr val="C8CDD3"/>
+                      </a:solidFill>
+                    </a:lnL>
+                    <a:solidFill>
+                      <a:srgbClr val="F4F6F8"/>
+                    </a:solidFill>
+                  </a:tcPr>
+                </a:tc>
+                <a:tc>
+                  <a:txBody>
+                    <a:bodyPr/>
+                    <a:lstStyle/>
+                    <a:p>
+                      <a:r>
+                        <a:rPr sz="800" b="0" i="0">
+                          <a:solidFill>
+                            <a:srgbClr val="1F2937"/>
+                          </a:solidFill>
+                          <a:latin typeface="Arial"/>
+                        </a:rPr>
+                        <a:t>Per the awaited detail</a:t>
+                      </a:r>
+                    </a:p>
+                  </a:txBody>
+                  <a:tcPr marL="91440" marR="91440" marT="45720" marB="45720">
+                    <a:lnB w="6350" cap="flat" cmpd="sng" algn="ctr">
+                      <a:solidFill>
+                        <a:srgbClr val="C8CDD3"/>
+                      </a:solidFill>
+                    </a:lnB>
+                    <a:lnT w="6350" cap="flat" cmpd="sng" algn="ctr">
+                      <a:solidFill>
+                        <a:srgbClr val="C8CDD3"/>
+                      </a:solidFill>
+                    </a:lnT>
+                    <a:lnR w="6350" cap="flat" cmpd="sng" algn="ctr">
+                      <a:solidFill>
+                        <a:srgbClr val="C8CDD3"/>
+                      </a:solidFill>
+                    </a:lnR>
+                    <a:lnL w="6350" cap="flat" cmpd="sng" algn="ctr">
+                      <a:solidFill>
+                        <a:srgbClr val="C8CDD3"/>
+                      </a:solidFill>
+                    </a:lnL>
+                    <a:solidFill>
+                      <a:srgbClr val="F4F6F8"/>
+                    </a:solidFill>
+                  </a:tcPr>
+                </a:tc>
+                <a:tc>
+                  <a:txBody>
+                    <a:bodyPr/>
+                    <a:lstStyle/>
+                    <a:p>
+                      <a:r>
+                        <a:rPr sz="800" b="0" i="0">
+                          <a:solidFill>
+                            <a:srgbClr val="1F2937"/>
+                          </a:solidFill>
+                          <a:latin typeface="Arial"/>
+                        </a:rPr>
+                        <a:t>LOC-03 sealed; RRMs re-fixed</a:t>
+                      </a:r>
+                    </a:p>
+                  </a:txBody>
+                  <a:tcPr marL="91440" marR="91440" marT="45720" marB="45720">
+                    <a:lnB w="6350" cap="flat" cmpd="sng" algn="ctr">
+                      <a:solidFill>
+                        <a:srgbClr val="C8CDD3"/>
+                      </a:solidFill>
+                    </a:lnB>
+                    <a:lnT w="6350" cap="flat" cmpd="sng" algn="ctr">
+                      <a:solidFill>
+                        <a:srgbClr val="C8CDD3"/>
+                      </a:solidFill>
+                    </a:lnT>
+                    <a:lnR w="6350" cap="flat" cmpd="sng" algn="ctr">
+                      <a:solidFill>
+                        <a:srgbClr val="C8CDD3"/>
+                      </a:solidFill>
+                    </a:lnR>
+                    <a:lnL w="6350" cap="flat" cmpd="sng" algn="ctr">
+                      <a:solidFill>
+                        <a:srgbClr val="C8CDD3"/>
+                      </a:solidFill>
+                    </a:lnL>
+                    <a:solidFill>
+                      <a:srgbClr val="F4F6F8"/>
+                    </a:solidFill>
+                  </a:tcPr>
+                </a:tc>
+              </a:tr>
+              <a:tr h="241442">
+                <a:tc>
+                  <a:txBody>
+                    <a:bodyPr/>
+                    <a:lstStyle/>
+                    <a:p>
+                      <a:r>
+                        <a:rPr sz="800" b="1" i="0">
+                          <a:solidFill>
+                            <a:srgbClr val="1F2937"/>
+                          </a:solidFill>
+                          <a:latin typeface="Arial"/>
+                        </a:rPr>
+                        <a:t>5</a:t>
                       </a:r>
                     </a:p>
                   </a:txBody>
@@ -55540,7 +57234,91 @@
                           </a:solidFill>
                           <a:latin typeface="Arial"/>
                         </a:rPr>
-                        <a:t>approx. 24 m / 95 m</a:t>
+                        <a:t>Saw cut, new base, cable, termination and testing</a:t>
+                      </a:r>
+                    </a:p>
+                  </a:txBody>
+                  <a:tcPr marL="91440" marR="91440" marT="45720" marB="45720">
+                    <a:lnB w="6350" cap="flat" cmpd="sng" algn="ctr">
+                      <a:solidFill>
+                        <a:srgbClr val="C8CDD3"/>
+                      </a:solidFill>
+                    </a:lnB>
+                    <a:lnT w="6350" cap="flat" cmpd="sng" algn="ctr">
+                      <a:solidFill>
+                        <a:srgbClr val="C8CDD3"/>
+                      </a:solidFill>
+                    </a:lnT>
+                    <a:lnR w="6350" cap="flat" cmpd="sng" algn="ctr">
+                      <a:solidFill>
+                        <a:srgbClr val="C8CDD3"/>
+                      </a:solidFill>
+                    </a:lnR>
+                    <a:lnL w="6350" cap="flat" cmpd="sng" algn="ctr">
+                      <a:solidFill>
+                        <a:srgbClr val="C8CDD3"/>
+                      </a:solidFill>
+                    </a:lnL>
+                    <a:solidFill>
+                      <a:srgbClr val="FFFFFF"/>
+                    </a:solidFill>
+                  </a:tcPr>
+                </a:tc>
+                <a:tc>
+                  <a:txBody>
+                    <a:bodyPr/>
+                    <a:lstStyle/>
+                    <a:p>
+                      <a:r>
+                        <a:rPr sz="800" b="0" i="0">
+                          <a:solidFill>
+                            <a:srgbClr val="1F2937"/>
+                          </a:solidFill>
+                          <a:latin typeface="Arial"/>
+                        </a:rPr>
+                        <a:t>LOC-02 · 1002</a:t>
+                      </a:r>
+                    </a:p>
+                  </a:txBody>
+                  <a:tcPr marL="91440" marR="91440" marT="45720" marB="45720">
+                    <a:lnB w="6350" cap="flat" cmpd="sng" algn="ctr">
+                      <a:solidFill>
+                        <a:srgbClr val="C8CDD3"/>
+                      </a:solidFill>
+                    </a:lnB>
+                    <a:lnT w="6350" cap="flat" cmpd="sng" algn="ctr">
+                      <a:solidFill>
+                        <a:srgbClr val="C8CDD3"/>
+                      </a:solidFill>
+                    </a:lnT>
+                    <a:lnR w="6350" cap="flat" cmpd="sng" algn="ctr">
+                      <a:solidFill>
+                        <a:srgbClr val="C8CDD3"/>
+                      </a:solidFill>
+                    </a:lnR>
+                    <a:lnL w="6350" cap="flat" cmpd="sng" algn="ctr">
+                      <a:solidFill>
+                        <a:srgbClr val="C8CDD3"/>
+                      </a:solidFill>
+                    </a:lnL>
+                    <a:solidFill>
+                      <a:srgbClr val="FFFFFF"/>
+                    </a:solidFill>
+                  </a:tcPr>
+                </a:tc>
+                <a:tc>
+                  <a:txBody>
+                    <a:bodyPr/>
+                    <a:lstStyle/>
+                    <a:p>
+                      <a:r>
+                        <a:rPr sz="800" b="0" i="0">
+                          <a:solidFill>
+                            <a:srgbClr val="1F2937"/>
+                          </a:solidFill>
+                          <a:latin typeface="Arial"/>
+                        </a:rPr>
+                        <a:t>approx. 24 m · 1 No. 12"</a:t>
                       </a:r>
                     </a:p>
                   </a:txBody>
@@ -55624,7 +57402,7 @@
                           </a:solidFill>
                           <a:latin typeface="Arial"/>
                         </a:rPr>
-                        <a:t>Both routes cut</a:t>
+                        <a:t>LOC-02 complete and tested</a:t>
                       </a:r>
                     </a:p>
                   </a:txBody>
@@ -55655,7 +57433,7 @@
                   </a:tcPr>
                 </a:tc>
               </a:tr>
-              <a:tr h="310413">
+              <a:tr h="241442">
                 <a:tc>
                   <a:txBody>
                     <a:bodyPr/>
@@ -55668,7 +57446,7 @@
                           </a:solidFill>
                           <a:latin typeface="Arial"/>
                         </a:rPr>
-                        <a:t>3</a:t>
+                        <a:t>5</a:t>
                       </a:r>
                     </a:p>
                   </a:txBody>
@@ -55710,7 +57488,7 @@
                           </a:solidFill>
                           <a:latin typeface="Arial"/>
                         </a:rPr>
-                        <a:t>Set the new side-entry shallow bases</a:t>
+                        <a:t>Reinstatement of the cut; re-fix RRM.555</a:t>
                       </a:r>
                     </a:p>
                   </a:txBody>
@@ -55752,7 +57530,7 @@
                           </a:solidFill>
                           <a:latin typeface="Arial"/>
                         </a:rPr>
-                        <a:t>LOC-02 / 03</a:t>
+                        <a:t>LOC-02 · 1002</a:t>
                       </a:r>
                     </a:p>
                   </a:txBody>
@@ -55794,7 +57572,261 @@
                           </a:solidFill>
                           <a:latin typeface="Arial"/>
                         </a:rPr>
-                        <a:t>1 No. 12" each</a:t>
+                        <a:t>approx. 24 m · 1 No. RRM</a:t>
+                      </a:r>
+                    </a:p>
+                  </a:txBody>
+                  <a:tcPr marL="91440" marR="91440" marT="45720" marB="45720">
+                    <a:lnB w="6350" cap="flat" cmpd="sng" algn="ctr">
+                      <a:solidFill>
+                        <a:srgbClr val="C8CDD3"/>
+                      </a:solidFill>
+                    </a:lnB>
+                    <a:lnT w="6350" cap="flat" cmpd="sng" algn="ctr">
+                      <a:solidFill>
+                        <a:srgbClr val="C8CDD3"/>
+                      </a:solidFill>
+                    </a:lnT>
+                    <a:lnR w="6350" cap="flat" cmpd="sng" algn="ctr">
+                      <a:solidFill>
+                        <a:srgbClr val="C8CDD3"/>
+                      </a:solidFill>
+                    </a:lnR>
+                    <a:lnL w="6350" cap="flat" cmpd="sng" algn="ctr">
+                      <a:solidFill>
+                        <a:srgbClr val="C8CDD3"/>
+                      </a:solidFill>
+                    </a:lnL>
+                    <a:solidFill>
+                      <a:srgbClr val="FFFFFF"/>
+                    </a:solidFill>
+                  </a:tcPr>
+                </a:tc>
+                <a:tc>
+                  <a:txBody>
+                    <a:bodyPr/>
+                    <a:lstStyle/>
+                    <a:p>
+                      <a:r>
+                        <a:rPr sz="800" b="0" i="0">
+                          <a:solidFill>
+                            <a:srgbClr val="1F2937"/>
+                          </a:solidFill>
+                          <a:latin typeface="Arial"/>
+                        </a:rPr>
+                        <a:t>Per the awaited detail</a:t>
+                      </a:r>
+                    </a:p>
+                  </a:txBody>
+                  <a:tcPr marL="91440" marR="91440" marT="45720" marB="45720">
+                    <a:lnB w="6350" cap="flat" cmpd="sng" algn="ctr">
+                      <a:solidFill>
+                        <a:srgbClr val="C8CDD3"/>
+                      </a:solidFill>
+                    </a:lnB>
+                    <a:lnT w="6350" cap="flat" cmpd="sng" algn="ctr">
+                      <a:solidFill>
+                        <a:srgbClr val="C8CDD3"/>
+                      </a:solidFill>
+                    </a:lnT>
+                    <a:lnR w="6350" cap="flat" cmpd="sng" algn="ctr">
+                      <a:solidFill>
+                        <a:srgbClr val="C8CDD3"/>
+                      </a:solidFill>
+                    </a:lnR>
+                    <a:lnL w="6350" cap="flat" cmpd="sng" algn="ctr">
+                      <a:solidFill>
+                        <a:srgbClr val="C8CDD3"/>
+                      </a:solidFill>
+                    </a:lnL>
+                    <a:solidFill>
+                      <a:srgbClr val="FFFFFF"/>
+                    </a:solidFill>
+                  </a:tcPr>
+                </a:tc>
+                <a:tc>
+                  <a:txBody>
+                    <a:bodyPr/>
+                    <a:lstStyle/>
+                    <a:p>
+                      <a:r>
+                        <a:rPr sz="800" b="0" i="0">
+                          <a:solidFill>
+                            <a:srgbClr val="1F2937"/>
+                          </a:solidFill>
+                          <a:latin typeface="Arial"/>
+                        </a:rPr>
+                        <a:t>LOC-02 sealed; RRM re-fixed</a:t>
+                      </a:r>
+                    </a:p>
+                  </a:txBody>
+                  <a:tcPr marL="91440" marR="91440" marT="45720" marB="45720">
+                    <a:lnB w="6350" cap="flat" cmpd="sng" algn="ctr">
+                      <a:solidFill>
+                        <a:srgbClr val="C8CDD3"/>
+                      </a:solidFill>
+                    </a:lnB>
+                    <a:lnT w="6350" cap="flat" cmpd="sng" algn="ctr">
+                      <a:solidFill>
+                        <a:srgbClr val="C8CDD3"/>
+                      </a:solidFill>
+                    </a:lnT>
+                    <a:lnR w="6350" cap="flat" cmpd="sng" algn="ctr">
+                      <a:solidFill>
+                        <a:srgbClr val="C8CDD3"/>
+                      </a:solidFill>
+                    </a:lnR>
+                    <a:lnL w="6350" cap="flat" cmpd="sng" algn="ctr">
+                      <a:solidFill>
+                        <a:srgbClr val="C8CDD3"/>
+                      </a:solidFill>
+                    </a:lnL>
+                    <a:solidFill>
+                      <a:srgbClr val="FFFFFF"/>
+                    </a:solidFill>
+                  </a:tcPr>
+                </a:tc>
+              </a:tr>
+              <a:tr h="241442">
+                <a:tc>
+                  <a:txBody>
+                    <a:bodyPr/>
+                    <a:lstStyle/>
+                    <a:p>
+                      <a:r>
+                        <a:rPr sz="800" b="1" i="0">
+                          <a:solidFill>
+                            <a:srgbClr val="1F2937"/>
+                          </a:solidFill>
+                          <a:latin typeface="Arial"/>
+                        </a:rPr>
+                        <a:t>5</a:t>
+                      </a:r>
+                    </a:p>
+                  </a:txBody>
+                  <a:tcPr marL="91440" marR="91440" marT="45720" marB="45720">
+                    <a:lnB w="6350" cap="flat" cmpd="sng" algn="ctr">
+                      <a:solidFill>
+                        <a:srgbClr val="C8CDD3"/>
+                      </a:solidFill>
+                    </a:lnB>
+                    <a:lnT w="6350" cap="flat" cmpd="sng" algn="ctr">
+                      <a:solidFill>
+                        <a:srgbClr val="C8CDD3"/>
+                      </a:solidFill>
+                    </a:lnT>
+                    <a:lnR w="6350" cap="flat" cmpd="sng" algn="ctr">
+                      <a:solidFill>
+                        <a:srgbClr val="C8CDD3"/>
+                      </a:solidFill>
+                    </a:lnR>
+                    <a:lnL w="6350" cap="flat" cmpd="sng" algn="ctr">
+                      <a:solidFill>
+                        <a:srgbClr val="C8CDD3"/>
+                      </a:solidFill>
+                    </a:lnL>
+                    <a:solidFill>
+                      <a:srgbClr val="FFFFFF"/>
+                    </a:solidFill>
+                  </a:tcPr>
+                </a:tc>
+                <a:tc>
+                  <a:txBody>
+                    <a:bodyPr/>
+                    <a:lstStyle/>
+                    <a:p>
+                      <a:r>
+                        <a:rPr sz="800" b="0" i="0">
+                          <a:solidFill>
+                            <a:srgbClr val="1F2937"/>
+                          </a:solidFill>
+                          <a:latin typeface="Arial"/>
+                        </a:rPr>
+                        <a:t>Testing and commissioning of the affected circuits — all three locations</a:t>
+                      </a:r>
+                    </a:p>
+                  </a:txBody>
+                  <a:tcPr marL="91440" marR="91440" marT="45720" marB="45720">
+                    <a:lnB w="6350" cap="flat" cmpd="sng" algn="ctr">
+                      <a:solidFill>
+                        <a:srgbClr val="C8CDD3"/>
+                      </a:solidFill>
+                    </a:lnB>
+                    <a:lnT w="6350" cap="flat" cmpd="sng" algn="ctr">
+                      <a:solidFill>
+                        <a:srgbClr val="C8CDD3"/>
+                      </a:solidFill>
+                    </a:lnT>
+                    <a:lnR w="6350" cap="flat" cmpd="sng" algn="ctr">
+                      <a:solidFill>
+                        <a:srgbClr val="C8CDD3"/>
+                      </a:solidFill>
+                    </a:lnR>
+                    <a:lnL w="6350" cap="flat" cmpd="sng" algn="ctr">
+                      <a:solidFill>
+                        <a:srgbClr val="C8CDD3"/>
+                      </a:solidFill>
+                    </a:lnL>
+                    <a:solidFill>
+                      <a:srgbClr val="FFFFFF"/>
+                    </a:solidFill>
+                  </a:tcPr>
+                </a:tc>
+                <a:tc>
+                  <a:txBody>
+                    <a:bodyPr/>
+                    <a:lstStyle/>
+                    <a:p>
+                      <a:r>
+                        <a:rPr sz="800" b="0" i="0">
+                          <a:solidFill>
+                            <a:srgbClr val="1F2937"/>
+                          </a:solidFill>
+                          <a:latin typeface="Arial"/>
+                        </a:rPr>
+                        <a:t>LOC-01 / 02 / 03</a:t>
+                      </a:r>
+                    </a:p>
+                  </a:txBody>
+                  <a:tcPr marL="91440" marR="91440" marT="45720" marB="45720">
+                    <a:lnB w="6350" cap="flat" cmpd="sng" algn="ctr">
+                      <a:solidFill>
+                        <a:srgbClr val="C8CDD3"/>
+                      </a:solidFill>
+                    </a:lnB>
+                    <a:lnT w="6350" cap="flat" cmpd="sng" algn="ctr">
+                      <a:solidFill>
+                        <a:srgbClr val="C8CDD3"/>
+                      </a:solidFill>
+                    </a:lnT>
+                    <a:lnR w="6350" cap="flat" cmpd="sng" algn="ctr">
+                      <a:solidFill>
+                        <a:srgbClr val="C8CDD3"/>
+                      </a:solidFill>
+                    </a:lnR>
+                    <a:lnL w="6350" cap="flat" cmpd="sng" algn="ctr">
+                      <a:solidFill>
+                        <a:srgbClr val="C8CDD3"/>
+                      </a:solidFill>
+                    </a:lnL>
+                    <a:solidFill>
+                      <a:srgbClr val="FFFFFF"/>
+                    </a:solidFill>
+                  </a:tcPr>
+                </a:tc>
+                <a:tc>
+                  <a:txBody>
+                    <a:bodyPr/>
+                    <a:lstStyle/>
+                    <a:p>
+                      <a:r>
+                        <a:rPr sz="800" b="0" i="0">
+                          <a:solidFill>
+                            <a:srgbClr val="1F2937"/>
+                          </a:solidFill>
+                          <a:latin typeface="Arial"/>
+                        </a:rPr>
+                        <a:t>4 No. circuits</a:t>
                       </a:r>
                     </a:p>
                   </a:txBody>
@@ -55878,7 +57910,7 @@
                           </a:solidFill>
                           <a:latin typeface="Arial"/>
                         </a:rPr>
-                        <a:t>2 No. bases set and levelled</a:t>
+                        <a:t>Circuits energised and proved</a:t>
                       </a:r>
                     </a:p>
                   </a:txBody>
@@ -55909,7 +57941,7 @@
                   </a:tcPr>
                 </a:tc>
               </a:tr>
-              <a:tr h="310413">
+              <a:tr h="241442">
                 <a:tc>
                   <a:txBody>
                     <a:bodyPr/>
@@ -55922,7 +57954,7 @@
                           </a:solidFill>
                           <a:latin typeface="Arial"/>
                         </a:rPr>
-                        <a:t>3</a:t>
+                        <a:t>5</a:t>
                       </a:r>
                     </a:p>
                   </a:txBody>
@@ -55964,1023 +57996,7 @@
                           </a:solidFill>
                           <a:latin typeface="Arial"/>
                         </a:rPr>
-                        <a:t>Lay new secondary cable through the saw cut — no joints, manhole to light</a:t>
-                      </a:r>
-                    </a:p>
-                  </a:txBody>
-                  <a:tcPr marL="91440" marR="91440" marT="45720" marB="45720">
-                    <a:lnB w="6350" cap="flat" cmpd="sng" algn="ctr">
-                      <a:solidFill>
-                        <a:srgbClr val="C8CDD3"/>
-                      </a:solidFill>
-                    </a:lnB>
-                    <a:lnT w="6350" cap="flat" cmpd="sng" algn="ctr">
-                      <a:solidFill>
-                        <a:srgbClr val="C8CDD3"/>
-                      </a:solidFill>
-                    </a:lnT>
-                    <a:lnR w="6350" cap="flat" cmpd="sng" algn="ctr">
-                      <a:solidFill>
-                        <a:srgbClr val="C8CDD3"/>
-                      </a:solidFill>
-                    </a:lnR>
-                    <a:lnL w="6350" cap="flat" cmpd="sng" algn="ctr">
-                      <a:solidFill>
-                        <a:srgbClr val="C8CDD3"/>
-                      </a:solidFill>
-                    </a:lnL>
-                    <a:solidFill>
-                      <a:srgbClr val="FFFFFF"/>
-                    </a:solidFill>
-                  </a:tcPr>
-                </a:tc>
-                <a:tc>
-                  <a:txBody>
-                    <a:bodyPr/>
-                    <a:lstStyle/>
-                    <a:p>
-                      <a:r>
-                        <a:rPr sz="800" b="0" i="0">
-                          <a:solidFill>
-                            <a:srgbClr val="1F2937"/>
-                          </a:solidFill>
-                          <a:latin typeface="Arial"/>
-                        </a:rPr>
-                        <a:t>LOC-01</a:t>
-                      </a:r>
-                    </a:p>
-                  </a:txBody>
-                  <a:tcPr marL="91440" marR="91440" marT="45720" marB="45720">
-                    <a:lnB w="6350" cap="flat" cmpd="sng" algn="ctr">
-                      <a:solidFill>
-                        <a:srgbClr val="C8CDD3"/>
-                      </a:solidFill>
-                    </a:lnB>
-                    <a:lnT w="6350" cap="flat" cmpd="sng" algn="ctr">
-                      <a:solidFill>
-                        <a:srgbClr val="C8CDD3"/>
-                      </a:solidFill>
-                    </a:lnT>
-                    <a:lnR w="6350" cap="flat" cmpd="sng" algn="ctr">
-                      <a:solidFill>
-                        <a:srgbClr val="C8CDD3"/>
-                      </a:solidFill>
-                    </a:lnR>
-                    <a:lnL w="6350" cap="flat" cmpd="sng" algn="ctr">
-                      <a:solidFill>
-                        <a:srgbClr val="C8CDD3"/>
-                      </a:solidFill>
-                    </a:lnL>
-                    <a:solidFill>
-                      <a:srgbClr val="FFFFFF"/>
-                    </a:solidFill>
-                  </a:tcPr>
-                </a:tc>
-                <a:tc>
-                  <a:txBody>
-                    <a:bodyPr/>
-                    <a:lstStyle/>
-                    <a:p>
-                      <a:r>
-                        <a:rPr sz="800" b="0" i="0">
-                          <a:solidFill>
-                            <a:srgbClr val="1F2937"/>
-                          </a:solidFill>
-                          <a:latin typeface="Arial"/>
-                        </a:rPr>
-                        <a:t>11 No. runs</a:t>
-                      </a:r>
-                    </a:p>
-                  </a:txBody>
-                  <a:tcPr marL="91440" marR="91440" marT="45720" marB="45720">
-                    <a:lnB w="6350" cap="flat" cmpd="sng" algn="ctr">
-                      <a:solidFill>
-                        <a:srgbClr val="C8CDD3"/>
-                      </a:solidFill>
-                    </a:lnB>
-                    <a:lnT w="6350" cap="flat" cmpd="sng" algn="ctr">
-                      <a:solidFill>
-                        <a:srgbClr val="C8CDD3"/>
-                      </a:solidFill>
-                    </a:lnT>
-                    <a:lnR w="6350" cap="flat" cmpd="sng" algn="ctr">
-                      <a:solidFill>
-                        <a:srgbClr val="C8CDD3"/>
-                      </a:solidFill>
-                    </a:lnR>
-                    <a:lnL w="6350" cap="flat" cmpd="sng" algn="ctr">
-                      <a:solidFill>
-                        <a:srgbClr val="C8CDD3"/>
-                      </a:solidFill>
-                    </a:lnL>
-                    <a:solidFill>
-                      <a:srgbClr val="FFFFFF"/>
-                    </a:solidFill>
-                  </a:tcPr>
-                </a:tc>
-                <a:tc>
-                  <a:txBody>
-                    <a:bodyPr/>
-                    <a:lstStyle/>
-                    <a:p>
-                      <a:r>
-                        <a:rPr sz="800" b="0" i="0">
-                          <a:solidFill>
-                            <a:srgbClr val="1F2937"/>
-                          </a:solidFill>
-                          <a:latin typeface="Arial"/>
-                        </a:rPr>
-                        <a:t>—</a:t>
-                      </a:r>
-                    </a:p>
-                  </a:txBody>
-                  <a:tcPr marL="91440" marR="91440" marT="45720" marB="45720">
-                    <a:lnB w="6350" cap="flat" cmpd="sng" algn="ctr">
-                      <a:solidFill>
-                        <a:srgbClr val="C8CDD3"/>
-                      </a:solidFill>
-                    </a:lnB>
-                    <a:lnT w="6350" cap="flat" cmpd="sng" algn="ctr">
-                      <a:solidFill>
-                        <a:srgbClr val="C8CDD3"/>
-                      </a:solidFill>
-                    </a:lnT>
-                    <a:lnR w="6350" cap="flat" cmpd="sng" algn="ctr">
-                      <a:solidFill>
-                        <a:srgbClr val="C8CDD3"/>
-                      </a:solidFill>
-                    </a:lnR>
-                    <a:lnL w="6350" cap="flat" cmpd="sng" algn="ctr">
-                      <a:solidFill>
-                        <a:srgbClr val="C8CDD3"/>
-                      </a:solidFill>
-                    </a:lnL>
-                    <a:solidFill>
-                      <a:srgbClr val="FFFFFF"/>
-                    </a:solidFill>
-                  </a:tcPr>
-                </a:tc>
-                <a:tc>
-                  <a:txBody>
-                    <a:bodyPr/>
-                    <a:lstStyle/>
-                    <a:p>
-                      <a:r>
-                        <a:rPr sz="800" b="0" i="0">
-                          <a:solidFill>
-                            <a:srgbClr val="1F2937"/>
-                          </a:solidFill>
-                          <a:latin typeface="Arial"/>
-                        </a:rPr>
-                        <a:t>LOC-01 cable in and protected</a:t>
-                      </a:r>
-                    </a:p>
-                  </a:txBody>
-                  <a:tcPr marL="91440" marR="91440" marT="45720" marB="45720">
-                    <a:lnB w="6350" cap="flat" cmpd="sng" algn="ctr">
-                      <a:solidFill>
-                        <a:srgbClr val="C8CDD3"/>
-                      </a:solidFill>
-                    </a:lnB>
-                    <a:lnT w="6350" cap="flat" cmpd="sng" algn="ctr">
-                      <a:solidFill>
-                        <a:srgbClr val="C8CDD3"/>
-                      </a:solidFill>
-                    </a:lnT>
-                    <a:lnR w="6350" cap="flat" cmpd="sng" algn="ctr">
-                      <a:solidFill>
-                        <a:srgbClr val="C8CDD3"/>
-                      </a:solidFill>
-                    </a:lnR>
-                    <a:lnL w="6350" cap="flat" cmpd="sng" algn="ctr">
-                      <a:solidFill>
-                        <a:srgbClr val="C8CDD3"/>
-                      </a:solidFill>
-                    </a:lnL>
-                    <a:solidFill>
-                      <a:srgbClr val="FFFFFF"/>
-                    </a:solidFill>
-                  </a:tcPr>
-                </a:tc>
-              </a:tr>
-              <a:tr h="310413">
-                <a:tc>
-                  <a:txBody>
-                    <a:bodyPr/>
-                    <a:lstStyle/>
-                    <a:p>
-                      <a:r>
-                        <a:rPr sz="800" b="1" i="0">
-                          <a:solidFill>
-                            <a:srgbClr val="1F2937"/>
-                          </a:solidFill>
-                          <a:latin typeface="Arial"/>
-                        </a:rPr>
-                        <a:t>4</a:t>
-                      </a:r>
-                    </a:p>
-                  </a:txBody>
-                  <a:tcPr marL="91440" marR="91440" marT="45720" marB="45720">
-                    <a:lnB w="6350" cap="flat" cmpd="sng" algn="ctr">
-                      <a:solidFill>
-                        <a:srgbClr val="C8CDD3"/>
-                      </a:solidFill>
-                    </a:lnB>
-                    <a:lnT w="6350" cap="flat" cmpd="sng" algn="ctr">
-                      <a:solidFill>
-                        <a:srgbClr val="C8CDD3"/>
-                      </a:solidFill>
-                    </a:lnT>
-                    <a:lnR w="6350" cap="flat" cmpd="sng" algn="ctr">
-                      <a:solidFill>
-                        <a:srgbClr val="C8CDD3"/>
-                      </a:solidFill>
-                    </a:lnR>
-                    <a:lnL w="6350" cap="flat" cmpd="sng" algn="ctr">
-                      <a:solidFill>
-                        <a:srgbClr val="C8CDD3"/>
-                      </a:solidFill>
-                    </a:lnL>
-                    <a:solidFill>
-                      <a:srgbClr val="F4F6F8"/>
-                    </a:solidFill>
-                  </a:tcPr>
-                </a:tc>
-                <a:tc>
-                  <a:txBody>
-                    <a:bodyPr/>
-                    <a:lstStyle/>
-                    <a:p>
-                      <a:r>
-                        <a:rPr sz="800" b="0" i="0">
-                          <a:solidFill>
-                            <a:srgbClr val="1F2937"/>
-                          </a:solidFill>
-                          <a:latin typeface="Arial"/>
-                        </a:rPr>
-                        <a:t>Lay new secondary cable through the saw cut</a:t>
-                      </a:r>
-                    </a:p>
-                  </a:txBody>
-                  <a:tcPr marL="91440" marR="91440" marT="45720" marB="45720">
-                    <a:lnB w="6350" cap="flat" cmpd="sng" algn="ctr">
-                      <a:solidFill>
-                        <a:srgbClr val="C8CDD3"/>
-                      </a:solidFill>
-                    </a:lnB>
-                    <a:lnT w="6350" cap="flat" cmpd="sng" algn="ctr">
-                      <a:solidFill>
-                        <a:srgbClr val="C8CDD3"/>
-                      </a:solidFill>
-                    </a:lnT>
-                    <a:lnR w="6350" cap="flat" cmpd="sng" algn="ctr">
-                      <a:solidFill>
-                        <a:srgbClr val="C8CDD3"/>
-                      </a:solidFill>
-                    </a:lnR>
-                    <a:lnL w="6350" cap="flat" cmpd="sng" algn="ctr">
-                      <a:solidFill>
-                        <a:srgbClr val="C8CDD3"/>
-                      </a:solidFill>
-                    </a:lnL>
-                    <a:solidFill>
-                      <a:srgbClr val="F4F6F8"/>
-                    </a:solidFill>
-                  </a:tcPr>
-                </a:tc>
-                <a:tc>
-                  <a:txBody>
-                    <a:bodyPr/>
-                    <a:lstStyle/>
-                    <a:p>
-                      <a:r>
-                        <a:rPr sz="800" b="0" i="0">
-                          <a:solidFill>
-                            <a:srgbClr val="1F2937"/>
-                          </a:solidFill>
-                          <a:latin typeface="Arial"/>
-                        </a:rPr>
-                        <a:t>LOC-02 / 03</a:t>
-                      </a:r>
-                    </a:p>
-                  </a:txBody>
-                  <a:tcPr marL="91440" marR="91440" marT="45720" marB="45720">
-                    <a:lnB w="6350" cap="flat" cmpd="sng" algn="ctr">
-                      <a:solidFill>
-                        <a:srgbClr val="C8CDD3"/>
-                      </a:solidFill>
-                    </a:lnB>
-                    <a:lnT w="6350" cap="flat" cmpd="sng" algn="ctr">
-                      <a:solidFill>
-                        <a:srgbClr val="C8CDD3"/>
-                      </a:solidFill>
-                    </a:lnT>
-                    <a:lnR w="6350" cap="flat" cmpd="sng" algn="ctr">
-                      <a:solidFill>
-                        <a:srgbClr val="C8CDD3"/>
-                      </a:solidFill>
-                    </a:lnR>
-                    <a:lnL w="6350" cap="flat" cmpd="sng" algn="ctr">
-                      <a:solidFill>
-                        <a:srgbClr val="C8CDD3"/>
-                      </a:solidFill>
-                    </a:lnL>
-                    <a:solidFill>
-                      <a:srgbClr val="F4F6F8"/>
-                    </a:solidFill>
-                  </a:tcPr>
-                </a:tc>
-                <a:tc>
-                  <a:txBody>
-                    <a:bodyPr/>
-                    <a:lstStyle/>
-                    <a:p>
-                      <a:r>
-                        <a:rPr sz="800" b="0" i="0">
-                          <a:solidFill>
-                            <a:srgbClr val="1F2937"/>
-                          </a:solidFill>
-                          <a:latin typeface="Arial"/>
-                        </a:rPr>
-                        <a:t>5 No. runs</a:t>
-                      </a:r>
-                    </a:p>
-                  </a:txBody>
-                  <a:tcPr marL="91440" marR="91440" marT="45720" marB="45720">
-                    <a:lnB w="6350" cap="flat" cmpd="sng" algn="ctr">
-                      <a:solidFill>
-                        <a:srgbClr val="C8CDD3"/>
-                      </a:solidFill>
-                    </a:lnB>
-                    <a:lnT w="6350" cap="flat" cmpd="sng" algn="ctr">
-                      <a:solidFill>
-                        <a:srgbClr val="C8CDD3"/>
-                      </a:solidFill>
-                    </a:lnT>
-                    <a:lnR w="6350" cap="flat" cmpd="sng" algn="ctr">
-                      <a:solidFill>
-                        <a:srgbClr val="C8CDD3"/>
-                      </a:solidFill>
-                    </a:lnR>
-                    <a:lnL w="6350" cap="flat" cmpd="sng" algn="ctr">
-                      <a:solidFill>
-                        <a:srgbClr val="C8CDD3"/>
-                      </a:solidFill>
-                    </a:lnL>
-                    <a:solidFill>
-                      <a:srgbClr val="F4F6F8"/>
-                    </a:solidFill>
-                  </a:tcPr>
-                </a:tc>
-                <a:tc>
-                  <a:txBody>
-                    <a:bodyPr/>
-                    <a:lstStyle/>
-                    <a:p>
-                      <a:r>
-                        <a:rPr sz="800" b="0" i="0">
-                          <a:solidFill>
-                            <a:srgbClr val="1F2937"/>
-                          </a:solidFill>
-                          <a:latin typeface="Arial"/>
-                        </a:rPr>
-                        <a:t>—</a:t>
-                      </a:r>
-                    </a:p>
-                  </a:txBody>
-                  <a:tcPr marL="91440" marR="91440" marT="45720" marB="45720">
-                    <a:lnB w="6350" cap="flat" cmpd="sng" algn="ctr">
-                      <a:solidFill>
-                        <a:srgbClr val="C8CDD3"/>
-                      </a:solidFill>
-                    </a:lnB>
-                    <a:lnT w="6350" cap="flat" cmpd="sng" algn="ctr">
-                      <a:solidFill>
-                        <a:srgbClr val="C8CDD3"/>
-                      </a:solidFill>
-                    </a:lnT>
-                    <a:lnR w="6350" cap="flat" cmpd="sng" algn="ctr">
-                      <a:solidFill>
-                        <a:srgbClr val="C8CDD3"/>
-                      </a:solidFill>
-                    </a:lnR>
-                    <a:lnL w="6350" cap="flat" cmpd="sng" algn="ctr">
-                      <a:solidFill>
-                        <a:srgbClr val="C8CDD3"/>
-                      </a:solidFill>
-                    </a:lnL>
-                    <a:solidFill>
-                      <a:srgbClr val="F4F6F8"/>
-                    </a:solidFill>
-                  </a:tcPr>
-                </a:tc>
-                <a:tc>
-                  <a:txBody>
-                    <a:bodyPr/>
-                    <a:lstStyle/>
-                    <a:p>
-                      <a:r>
-                        <a:rPr sz="800" b="0" i="0">
-                          <a:solidFill>
-                            <a:srgbClr val="1F2937"/>
-                          </a:solidFill>
-                          <a:latin typeface="Arial"/>
-                        </a:rPr>
-                        <a:t>All 16 No. runs cabled</a:t>
-                      </a:r>
-                    </a:p>
-                  </a:txBody>
-                  <a:tcPr marL="91440" marR="91440" marT="45720" marB="45720">
-                    <a:lnB w="6350" cap="flat" cmpd="sng" algn="ctr">
-                      <a:solidFill>
-                        <a:srgbClr val="C8CDD3"/>
-                      </a:solidFill>
-                    </a:lnB>
-                    <a:lnT w="6350" cap="flat" cmpd="sng" algn="ctr">
-                      <a:solidFill>
-                        <a:srgbClr val="C8CDD3"/>
-                      </a:solidFill>
-                    </a:lnT>
-                    <a:lnR w="6350" cap="flat" cmpd="sng" algn="ctr">
-                      <a:solidFill>
-                        <a:srgbClr val="C8CDD3"/>
-                      </a:solidFill>
-                    </a:lnR>
-                    <a:lnL w="6350" cap="flat" cmpd="sng" algn="ctr">
-                      <a:solidFill>
-                        <a:srgbClr val="C8CDD3"/>
-                      </a:solidFill>
-                    </a:lnL>
-                    <a:solidFill>
-                      <a:srgbClr val="F4F6F8"/>
-                    </a:solidFill>
-                  </a:tcPr>
-                </a:tc>
-              </a:tr>
-              <a:tr h="310413">
-                <a:tc>
-                  <a:txBody>
-                    <a:bodyPr/>
-                    <a:lstStyle/>
-                    <a:p>
-                      <a:r>
-                        <a:rPr sz="800" b="1" i="0">
-                          <a:solidFill>
-                            <a:srgbClr val="1F2937"/>
-                          </a:solidFill>
-                          <a:latin typeface="Arial"/>
-                        </a:rPr>
-                        <a:t>4</a:t>
-                      </a:r>
-                    </a:p>
-                  </a:txBody>
-                  <a:tcPr marL="91440" marR="91440" marT="45720" marB="45720">
-                    <a:lnB w="6350" cap="flat" cmpd="sng" algn="ctr">
-                      <a:solidFill>
-                        <a:srgbClr val="C8CDD3"/>
-                      </a:solidFill>
-                    </a:lnB>
-                    <a:lnT w="6350" cap="flat" cmpd="sng" algn="ctr">
-                      <a:solidFill>
-                        <a:srgbClr val="C8CDD3"/>
-                      </a:solidFill>
-                    </a:lnT>
-                    <a:lnR w="6350" cap="flat" cmpd="sng" algn="ctr">
-                      <a:solidFill>
-                        <a:srgbClr val="C8CDD3"/>
-                      </a:solidFill>
-                    </a:lnR>
-                    <a:lnL w="6350" cap="flat" cmpd="sng" algn="ctr">
-                      <a:solidFill>
-                        <a:srgbClr val="C8CDD3"/>
-                      </a:solidFill>
-                    </a:lnL>
-                    <a:solidFill>
-                      <a:srgbClr val="F4F6F8"/>
-                    </a:solidFill>
-                  </a:tcPr>
-                </a:tc>
-                <a:tc>
-                  <a:txBody>
-                    <a:bodyPr/>
-                    <a:lstStyle/>
-                    <a:p>
-                      <a:r>
-                        <a:rPr sz="800" b="0" i="0">
-                          <a:solidFill>
-                            <a:srgbClr val="1F2937"/>
-                          </a:solidFill>
-                          <a:latin typeface="Arial"/>
-                        </a:rPr>
-                        <a:t>Cable termination at the bases and at the manholes</a:t>
-                      </a:r>
-                    </a:p>
-                  </a:txBody>
-                  <a:tcPr marL="91440" marR="91440" marT="45720" marB="45720">
-                    <a:lnB w="6350" cap="flat" cmpd="sng" algn="ctr">
-                      <a:solidFill>
-                        <a:srgbClr val="C8CDD3"/>
-                      </a:solidFill>
-                    </a:lnB>
-                    <a:lnT w="6350" cap="flat" cmpd="sng" algn="ctr">
-                      <a:solidFill>
-                        <a:srgbClr val="C8CDD3"/>
-                      </a:solidFill>
-                    </a:lnT>
-                    <a:lnR w="6350" cap="flat" cmpd="sng" algn="ctr">
-                      <a:solidFill>
-                        <a:srgbClr val="C8CDD3"/>
-                      </a:solidFill>
-                    </a:lnR>
-                    <a:lnL w="6350" cap="flat" cmpd="sng" algn="ctr">
-                      <a:solidFill>
-                        <a:srgbClr val="C8CDD3"/>
-                      </a:solidFill>
-                    </a:lnL>
-                    <a:solidFill>
-                      <a:srgbClr val="F4F6F8"/>
-                    </a:solidFill>
-                  </a:tcPr>
-                </a:tc>
-                <a:tc>
-                  <a:txBody>
-                    <a:bodyPr/>
-                    <a:lstStyle/>
-                    <a:p>
-                      <a:r>
-                        <a:rPr sz="800" b="0" i="0">
-                          <a:solidFill>
-                            <a:srgbClr val="1F2937"/>
-                          </a:solidFill>
-                          <a:latin typeface="Arial"/>
-                        </a:rPr>
-                        <a:t>LOC-01 / 02 / 03</a:t>
-                      </a:r>
-                    </a:p>
-                  </a:txBody>
-                  <a:tcPr marL="91440" marR="91440" marT="45720" marB="45720">
-                    <a:lnB w="6350" cap="flat" cmpd="sng" algn="ctr">
-                      <a:solidFill>
-                        <a:srgbClr val="C8CDD3"/>
-                      </a:solidFill>
-                    </a:lnB>
-                    <a:lnT w="6350" cap="flat" cmpd="sng" algn="ctr">
-                      <a:solidFill>
-                        <a:srgbClr val="C8CDD3"/>
-                      </a:solidFill>
-                    </a:lnT>
-                    <a:lnR w="6350" cap="flat" cmpd="sng" algn="ctr">
-                      <a:solidFill>
-                        <a:srgbClr val="C8CDD3"/>
-                      </a:solidFill>
-                    </a:lnR>
-                    <a:lnL w="6350" cap="flat" cmpd="sng" algn="ctr">
-                      <a:solidFill>
-                        <a:srgbClr val="C8CDD3"/>
-                      </a:solidFill>
-                    </a:lnL>
-                    <a:solidFill>
-                      <a:srgbClr val="F4F6F8"/>
-                    </a:solidFill>
-                  </a:tcPr>
-                </a:tc>
-                <a:tc>
-                  <a:txBody>
-                    <a:bodyPr/>
-                    <a:lstStyle/>
-                    <a:p>
-                      <a:r>
-                        <a:rPr sz="800" b="0" i="0">
-                          <a:solidFill>
-                            <a:srgbClr val="1F2937"/>
-                          </a:solidFill>
-                          <a:latin typeface="Arial"/>
-                        </a:rPr>
-                        <a:t>16 No. fittings</a:t>
-                      </a:r>
-                    </a:p>
-                  </a:txBody>
-                  <a:tcPr marL="91440" marR="91440" marT="45720" marB="45720">
-                    <a:lnB w="6350" cap="flat" cmpd="sng" algn="ctr">
-                      <a:solidFill>
-                        <a:srgbClr val="C8CDD3"/>
-                      </a:solidFill>
-                    </a:lnB>
-                    <a:lnT w="6350" cap="flat" cmpd="sng" algn="ctr">
-                      <a:solidFill>
-                        <a:srgbClr val="C8CDD3"/>
-                      </a:solidFill>
-                    </a:lnT>
-                    <a:lnR w="6350" cap="flat" cmpd="sng" algn="ctr">
-                      <a:solidFill>
-                        <a:srgbClr val="C8CDD3"/>
-                      </a:solidFill>
-                    </a:lnR>
-                    <a:lnL w="6350" cap="flat" cmpd="sng" algn="ctr">
-                      <a:solidFill>
-                        <a:srgbClr val="C8CDD3"/>
-                      </a:solidFill>
-                    </a:lnL>
-                    <a:solidFill>
-                      <a:srgbClr val="F4F6F8"/>
-                    </a:solidFill>
-                  </a:tcPr>
-                </a:tc>
-                <a:tc>
-                  <a:txBody>
-                    <a:bodyPr/>
-                    <a:lstStyle/>
-                    <a:p>
-                      <a:r>
-                        <a:rPr sz="800" b="0" i="0">
-                          <a:solidFill>
-                            <a:srgbClr val="1F2937"/>
-                          </a:solidFill>
-                          <a:latin typeface="Arial"/>
-                        </a:rPr>
-                        <a:t>—</a:t>
-                      </a:r>
-                    </a:p>
-                  </a:txBody>
-                  <a:tcPr marL="91440" marR="91440" marT="45720" marB="45720">
-                    <a:lnB w="6350" cap="flat" cmpd="sng" algn="ctr">
-                      <a:solidFill>
-                        <a:srgbClr val="C8CDD3"/>
-                      </a:solidFill>
-                    </a:lnB>
-                    <a:lnT w="6350" cap="flat" cmpd="sng" algn="ctr">
-                      <a:solidFill>
-                        <a:srgbClr val="C8CDD3"/>
-                      </a:solidFill>
-                    </a:lnT>
-                    <a:lnR w="6350" cap="flat" cmpd="sng" algn="ctr">
-                      <a:solidFill>
-                        <a:srgbClr val="C8CDD3"/>
-                      </a:solidFill>
-                    </a:lnR>
-                    <a:lnL w="6350" cap="flat" cmpd="sng" algn="ctr">
-                      <a:solidFill>
-                        <a:srgbClr val="C8CDD3"/>
-                      </a:solidFill>
-                    </a:lnL>
-                    <a:solidFill>
-                      <a:srgbClr val="F4F6F8"/>
-                    </a:solidFill>
-                  </a:tcPr>
-                </a:tc>
-                <a:tc>
-                  <a:txBody>
-                    <a:bodyPr/>
-                    <a:lstStyle/>
-                    <a:p>
-                      <a:r>
-                        <a:rPr sz="800" b="0" i="0">
-                          <a:solidFill>
-                            <a:srgbClr val="1F2937"/>
-                          </a:solidFill>
-                          <a:latin typeface="Arial"/>
-                        </a:rPr>
-                        <a:t>Terminations made off</a:t>
-                      </a:r>
-                    </a:p>
-                  </a:txBody>
-                  <a:tcPr marL="91440" marR="91440" marT="45720" marB="45720">
-                    <a:lnB w="6350" cap="flat" cmpd="sng" algn="ctr">
-                      <a:solidFill>
-                        <a:srgbClr val="C8CDD3"/>
-                      </a:solidFill>
-                    </a:lnB>
-                    <a:lnT w="6350" cap="flat" cmpd="sng" algn="ctr">
-                      <a:solidFill>
-                        <a:srgbClr val="C8CDD3"/>
-                      </a:solidFill>
-                    </a:lnT>
-                    <a:lnR w="6350" cap="flat" cmpd="sng" algn="ctr">
-                      <a:solidFill>
-                        <a:srgbClr val="C8CDD3"/>
-                      </a:solidFill>
-                    </a:lnR>
-                    <a:lnL w="6350" cap="flat" cmpd="sng" algn="ctr">
-                      <a:solidFill>
-                        <a:srgbClr val="C8CDD3"/>
-                      </a:solidFill>
-                    </a:lnL>
-                    <a:solidFill>
-                      <a:srgbClr val="F4F6F8"/>
-                    </a:solidFill>
-                  </a:tcPr>
-                </a:tc>
-              </a:tr>
-              <a:tr h="310413">
-                <a:tc>
-                  <a:txBody>
-                    <a:bodyPr/>
-                    <a:lstStyle/>
-                    <a:p>
-                      <a:r>
-                        <a:rPr sz="800" b="1" i="0">
-                          <a:solidFill>
-                            <a:srgbClr val="1F2937"/>
-                          </a:solidFill>
-                          <a:latin typeface="Arial"/>
-                        </a:rPr>
-                        <a:t>4</a:t>
-                      </a:r>
-                    </a:p>
-                  </a:txBody>
-                  <a:tcPr marL="91440" marR="91440" marT="45720" marB="45720">
-                    <a:lnB w="6350" cap="flat" cmpd="sng" algn="ctr">
-                      <a:solidFill>
-                        <a:srgbClr val="C8CDD3"/>
-                      </a:solidFill>
-                    </a:lnB>
-                    <a:lnT w="6350" cap="flat" cmpd="sng" algn="ctr">
-                      <a:solidFill>
-                        <a:srgbClr val="C8CDD3"/>
-                      </a:solidFill>
-                    </a:lnT>
-                    <a:lnR w="6350" cap="flat" cmpd="sng" algn="ctr">
-                      <a:solidFill>
-                        <a:srgbClr val="C8CDD3"/>
-                      </a:solidFill>
-                    </a:lnR>
-                    <a:lnL w="6350" cap="flat" cmpd="sng" algn="ctr">
-                      <a:solidFill>
-                        <a:srgbClr val="C8CDD3"/>
-                      </a:solidFill>
-                    </a:lnL>
-                    <a:solidFill>
-                      <a:srgbClr val="F4F6F8"/>
-                    </a:solidFill>
-                  </a:tcPr>
-                </a:tc>
-                <a:tc>
-                  <a:txBody>
-                    <a:bodyPr/>
-                    <a:lstStyle/>
-                    <a:p>
-                      <a:r>
-                        <a:rPr sz="800" b="0" i="0">
-                          <a:solidFill>
-                            <a:srgbClr val="1F2937"/>
-                          </a:solidFill>
-                          <a:latin typeface="Arial"/>
-                        </a:rPr>
-                        <a:t>Insulation resistance and continuity testing</a:t>
-                      </a:r>
-                    </a:p>
-                  </a:txBody>
-                  <a:tcPr marL="91440" marR="91440" marT="45720" marB="45720">
-                    <a:lnB w="6350" cap="flat" cmpd="sng" algn="ctr">
-                      <a:solidFill>
-                        <a:srgbClr val="C8CDD3"/>
-                      </a:solidFill>
-                    </a:lnB>
-                    <a:lnT w="6350" cap="flat" cmpd="sng" algn="ctr">
-                      <a:solidFill>
-                        <a:srgbClr val="C8CDD3"/>
-                      </a:solidFill>
-                    </a:lnT>
-                    <a:lnR w="6350" cap="flat" cmpd="sng" algn="ctr">
-                      <a:solidFill>
-                        <a:srgbClr val="C8CDD3"/>
-                      </a:solidFill>
-                    </a:lnR>
-                    <a:lnL w="6350" cap="flat" cmpd="sng" algn="ctr">
-                      <a:solidFill>
-                        <a:srgbClr val="C8CDD3"/>
-                      </a:solidFill>
-                    </a:lnL>
-                    <a:solidFill>
-                      <a:srgbClr val="F4F6F8"/>
-                    </a:solidFill>
-                  </a:tcPr>
-                </a:tc>
-                <a:tc>
-                  <a:txBody>
-                    <a:bodyPr/>
-                    <a:lstStyle/>
-                    <a:p>
-                      <a:r>
-                        <a:rPr sz="800" b="0" i="0">
-                          <a:solidFill>
-                            <a:srgbClr val="1F2937"/>
-                          </a:solidFill>
-                          <a:latin typeface="Arial"/>
-                        </a:rPr>
-                        <a:t>LOC-01 / 02 / 03</a:t>
-                      </a:r>
-                    </a:p>
-                  </a:txBody>
-                  <a:tcPr marL="91440" marR="91440" marT="45720" marB="45720">
-                    <a:lnB w="6350" cap="flat" cmpd="sng" algn="ctr">
-                      <a:solidFill>
-                        <a:srgbClr val="C8CDD3"/>
-                      </a:solidFill>
-                    </a:lnB>
-                    <a:lnT w="6350" cap="flat" cmpd="sng" algn="ctr">
-                      <a:solidFill>
-                        <a:srgbClr val="C8CDD3"/>
-                      </a:solidFill>
-                    </a:lnT>
-                    <a:lnR w="6350" cap="flat" cmpd="sng" algn="ctr">
-                      <a:solidFill>
-                        <a:srgbClr val="C8CDD3"/>
-                      </a:solidFill>
-                    </a:lnR>
-                    <a:lnL w="6350" cap="flat" cmpd="sng" algn="ctr">
-                      <a:solidFill>
-                        <a:srgbClr val="C8CDD3"/>
-                      </a:solidFill>
-                    </a:lnL>
-                    <a:solidFill>
-                      <a:srgbClr val="F4F6F8"/>
-                    </a:solidFill>
-                  </a:tcPr>
-                </a:tc>
-                <a:tc>
-                  <a:txBody>
-                    <a:bodyPr/>
-                    <a:lstStyle/>
-                    <a:p>
-                      <a:r>
-                        <a:rPr sz="800" b="0" i="0">
-                          <a:solidFill>
-                            <a:srgbClr val="1F2937"/>
-                          </a:solidFill>
-                          <a:latin typeface="Arial"/>
-                        </a:rPr>
-                        <a:t>4 No. circuits</a:t>
-                      </a:r>
-                    </a:p>
-                  </a:txBody>
-                  <a:tcPr marL="91440" marR="91440" marT="45720" marB="45720">
-                    <a:lnB w="6350" cap="flat" cmpd="sng" algn="ctr">
-                      <a:solidFill>
-                        <a:srgbClr val="C8CDD3"/>
-                      </a:solidFill>
-                    </a:lnB>
-                    <a:lnT w="6350" cap="flat" cmpd="sng" algn="ctr">
-                      <a:solidFill>
-                        <a:srgbClr val="C8CDD3"/>
-                      </a:solidFill>
-                    </a:lnT>
-                    <a:lnR w="6350" cap="flat" cmpd="sng" algn="ctr">
-                      <a:solidFill>
-                        <a:srgbClr val="C8CDD3"/>
-                      </a:solidFill>
-                    </a:lnR>
-                    <a:lnL w="6350" cap="flat" cmpd="sng" algn="ctr">
-                      <a:solidFill>
-                        <a:srgbClr val="C8CDD3"/>
-                      </a:solidFill>
-                    </a:lnL>
-                    <a:solidFill>
-                      <a:srgbClr val="F4F6F8"/>
-                    </a:solidFill>
-                  </a:tcPr>
-                </a:tc>
-                <a:tc>
-                  <a:txBody>
-                    <a:bodyPr/>
-                    <a:lstStyle/>
-                    <a:p>
-                      <a:r>
-                        <a:rPr sz="800" b="0" i="0">
-                          <a:solidFill>
-                            <a:srgbClr val="1F2937"/>
-                          </a:solidFill>
-                          <a:latin typeface="Arial"/>
-                        </a:rPr>
-                        <a:t>—</a:t>
-                      </a:r>
-                    </a:p>
-                  </a:txBody>
-                  <a:tcPr marL="91440" marR="91440" marT="45720" marB="45720">
-                    <a:lnB w="6350" cap="flat" cmpd="sng" algn="ctr">
-                      <a:solidFill>
-                        <a:srgbClr val="C8CDD3"/>
-                      </a:solidFill>
-                    </a:lnB>
-                    <a:lnT w="6350" cap="flat" cmpd="sng" algn="ctr">
-                      <a:solidFill>
-                        <a:srgbClr val="C8CDD3"/>
-                      </a:solidFill>
-                    </a:lnT>
-                    <a:lnR w="6350" cap="flat" cmpd="sng" algn="ctr">
-                      <a:solidFill>
-                        <a:srgbClr val="C8CDD3"/>
-                      </a:solidFill>
-                    </a:lnR>
-                    <a:lnL w="6350" cap="flat" cmpd="sng" algn="ctr">
-                      <a:solidFill>
-                        <a:srgbClr val="C8CDD3"/>
-                      </a:solidFill>
-                    </a:lnL>
-                    <a:solidFill>
-                      <a:srgbClr val="F4F6F8"/>
-                    </a:solidFill>
-                  </a:tcPr>
-                </a:tc>
-                <a:tc>
-                  <a:txBody>
-                    <a:bodyPr/>
-                    <a:lstStyle/>
-                    <a:p>
-                      <a:r>
-                        <a:rPr sz="800" b="0" i="0">
-                          <a:solidFill>
-                            <a:srgbClr val="1F2937"/>
-                          </a:solidFill>
-                          <a:latin typeface="Arial"/>
-                        </a:rPr>
-                        <a:t>Test records issued</a:t>
-                      </a:r>
-                    </a:p>
-                  </a:txBody>
-                  <a:tcPr marL="91440" marR="91440" marT="45720" marB="45720">
-                    <a:lnB w="6350" cap="flat" cmpd="sng" algn="ctr">
-                      <a:solidFill>
-                        <a:srgbClr val="C8CDD3"/>
-                      </a:solidFill>
-                    </a:lnB>
-                    <a:lnT w="6350" cap="flat" cmpd="sng" algn="ctr">
-                      <a:solidFill>
-                        <a:srgbClr val="C8CDD3"/>
-                      </a:solidFill>
-                    </a:lnT>
-                    <a:lnR w="6350" cap="flat" cmpd="sng" algn="ctr">
-                      <a:solidFill>
-                        <a:srgbClr val="C8CDD3"/>
-                      </a:solidFill>
-                    </a:lnR>
-                    <a:lnL w="6350" cap="flat" cmpd="sng" algn="ctr">
-                      <a:solidFill>
-                        <a:srgbClr val="C8CDD3"/>
-                      </a:solidFill>
-                    </a:lnL>
-                    <a:solidFill>
-                      <a:srgbClr val="F4F6F8"/>
-                    </a:solidFill>
-                  </a:tcPr>
-                </a:tc>
-              </a:tr>
-              <a:tr h="310413">
-                <a:tc>
-                  <a:txBody>
-                    <a:bodyPr/>
-                    <a:lstStyle/>
-                    <a:p>
-                      <a:r>
-                        <a:rPr sz="800" b="1" i="0">
-                          <a:solidFill>
-                            <a:srgbClr val="1F2937"/>
-                          </a:solidFill>
-                          <a:latin typeface="Arial"/>
-                        </a:rPr>
-                        <a:t>5</a:t>
-                      </a:r>
-                    </a:p>
-                  </a:txBody>
-                  <a:tcPr marL="91440" marR="91440" marT="45720" marB="45720">
-                    <a:lnB w="6350" cap="flat" cmpd="sng" algn="ctr">
-                      <a:solidFill>
-                        <a:srgbClr val="C8CDD3"/>
-                      </a:solidFill>
-                    </a:lnB>
-                    <a:lnT w="6350" cap="flat" cmpd="sng" algn="ctr">
-                      <a:solidFill>
-                        <a:srgbClr val="C8CDD3"/>
-                      </a:solidFill>
-                    </a:lnT>
-                    <a:lnR w="6350" cap="flat" cmpd="sng" algn="ctr">
-                      <a:solidFill>
-                        <a:srgbClr val="C8CDD3"/>
-                      </a:solidFill>
-                    </a:lnR>
-                    <a:lnL w="6350" cap="flat" cmpd="sng" algn="ctr">
-                      <a:solidFill>
-                        <a:srgbClr val="C8CDD3"/>
-                      </a:solidFill>
-                    </a:lnL>
-                    <a:solidFill>
-                      <a:srgbClr val="FFFFFF"/>
-                    </a:solidFill>
-                  </a:tcPr>
-                </a:tc>
-                <a:tc>
-                  <a:txBody>
-                    <a:bodyPr/>
-                    <a:lstStyle/>
-                    <a:p>
-                      <a:r>
-                        <a:rPr sz="800" b="0" i="0">
-                          <a:solidFill>
-                            <a:srgbClr val="1F2937"/>
-                          </a:solidFill>
-                          <a:latin typeface="Arial"/>
-                        </a:rPr>
-                        <a:t>Backfill, sealant and pavement reinstatement of the saw cut</a:t>
+                        <a:t>Final functionality check, then handover to Operations</a:t>
                       </a:r>
                     </a:p>
                   </a:txBody>
@@ -57064,768 +58080,6 @@
                           </a:solidFill>
                           <a:latin typeface="Arial"/>
                         </a:rPr>
-                        <a:t>approx. 420 m</a:t>
-                      </a:r>
-                    </a:p>
-                  </a:txBody>
-                  <a:tcPr marL="91440" marR="91440" marT="45720" marB="45720">
-                    <a:lnB w="6350" cap="flat" cmpd="sng" algn="ctr">
-                      <a:solidFill>
-                        <a:srgbClr val="C8CDD3"/>
-                      </a:solidFill>
-                    </a:lnB>
-                    <a:lnT w="6350" cap="flat" cmpd="sng" algn="ctr">
-                      <a:solidFill>
-                        <a:srgbClr val="C8CDD3"/>
-                      </a:solidFill>
-                    </a:lnT>
-                    <a:lnR w="6350" cap="flat" cmpd="sng" algn="ctr">
-                      <a:solidFill>
-                        <a:srgbClr val="C8CDD3"/>
-                      </a:solidFill>
-                    </a:lnR>
-                    <a:lnL w="6350" cap="flat" cmpd="sng" algn="ctr">
-                      <a:solidFill>
-                        <a:srgbClr val="C8CDD3"/>
-                      </a:solidFill>
-                    </a:lnL>
-                    <a:solidFill>
-                      <a:srgbClr val="FFFFFF"/>
-                    </a:solidFill>
-                  </a:tcPr>
-                </a:tc>
-                <a:tc>
-                  <a:txBody>
-                    <a:bodyPr/>
-                    <a:lstStyle/>
-                    <a:p>
-                      <a:r>
-                        <a:rPr sz="800" b="0" i="0">
-                          <a:solidFill>
-                            <a:srgbClr val="1F2937"/>
-                          </a:solidFill>
-                          <a:latin typeface="Arial"/>
-                        </a:rPr>
-                        <a:t>Per the awaited detail</a:t>
-                      </a:r>
-                    </a:p>
-                  </a:txBody>
-                  <a:tcPr marL="91440" marR="91440" marT="45720" marB="45720">
-                    <a:lnB w="6350" cap="flat" cmpd="sng" algn="ctr">
-                      <a:solidFill>
-                        <a:srgbClr val="C8CDD3"/>
-                      </a:solidFill>
-                    </a:lnB>
-                    <a:lnT w="6350" cap="flat" cmpd="sng" algn="ctr">
-                      <a:solidFill>
-                        <a:srgbClr val="C8CDD3"/>
-                      </a:solidFill>
-                    </a:lnT>
-                    <a:lnR w="6350" cap="flat" cmpd="sng" algn="ctr">
-                      <a:solidFill>
-                        <a:srgbClr val="C8CDD3"/>
-                      </a:solidFill>
-                    </a:lnR>
-                    <a:lnL w="6350" cap="flat" cmpd="sng" algn="ctr">
-                      <a:solidFill>
-                        <a:srgbClr val="C8CDD3"/>
-                      </a:solidFill>
-                    </a:lnL>
-                    <a:solidFill>
-                      <a:srgbClr val="FFFFFF"/>
-                    </a:solidFill>
-                  </a:tcPr>
-                </a:tc>
-                <a:tc>
-                  <a:txBody>
-                    <a:bodyPr/>
-                    <a:lstStyle/>
-                    <a:p>
-                      <a:r>
-                        <a:rPr sz="800" b="0" i="0">
-                          <a:solidFill>
-                            <a:srgbClr val="1F2937"/>
-                          </a:solidFill>
-                          <a:latin typeface="Arial"/>
-                        </a:rPr>
-                        <a:t>Cut sealed; cure period started</a:t>
-                      </a:r>
-                    </a:p>
-                  </a:txBody>
-                  <a:tcPr marL="91440" marR="91440" marT="45720" marB="45720">
-                    <a:lnB w="6350" cap="flat" cmpd="sng" algn="ctr">
-                      <a:solidFill>
-                        <a:srgbClr val="C8CDD3"/>
-                      </a:solidFill>
-                    </a:lnB>
-                    <a:lnT w="6350" cap="flat" cmpd="sng" algn="ctr">
-                      <a:solidFill>
-                        <a:srgbClr val="C8CDD3"/>
-                      </a:solidFill>
-                    </a:lnT>
-                    <a:lnR w="6350" cap="flat" cmpd="sng" algn="ctr">
-                      <a:solidFill>
-                        <a:srgbClr val="C8CDD3"/>
-                      </a:solidFill>
-                    </a:lnR>
-                    <a:lnL w="6350" cap="flat" cmpd="sng" algn="ctr">
-                      <a:solidFill>
-                        <a:srgbClr val="C8CDD3"/>
-                      </a:solidFill>
-                    </a:lnL>
-                    <a:solidFill>
-                      <a:srgbClr val="FFFFFF"/>
-                    </a:solidFill>
-                  </a:tcPr>
-                </a:tc>
-              </a:tr>
-              <a:tr h="310413">
-                <a:tc>
-                  <a:txBody>
-                    <a:bodyPr/>
-                    <a:lstStyle/>
-                    <a:p>
-                      <a:r>
-                        <a:rPr sz="800" b="1" i="0">
-                          <a:solidFill>
-                            <a:srgbClr val="1F2937"/>
-                          </a:solidFill>
-                          <a:latin typeface="Arial"/>
-                        </a:rPr>
-                        <a:t>5</a:t>
-                      </a:r>
-                    </a:p>
-                  </a:txBody>
-                  <a:tcPr marL="91440" marR="91440" marT="45720" marB="45720">
-                    <a:lnB w="6350" cap="flat" cmpd="sng" algn="ctr">
-                      <a:solidFill>
-                        <a:srgbClr val="C8CDD3"/>
-                      </a:solidFill>
-                    </a:lnB>
-                    <a:lnT w="6350" cap="flat" cmpd="sng" algn="ctr">
-                      <a:solidFill>
-                        <a:srgbClr val="C8CDD3"/>
-                      </a:solidFill>
-                    </a:lnT>
-                    <a:lnR w="6350" cap="flat" cmpd="sng" algn="ctr">
-                      <a:solidFill>
-                        <a:srgbClr val="C8CDD3"/>
-                      </a:solidFill>
-                    </a:lnR>
-                    <a:lnL w="6350" cap="flat" cmpd="sng" algn="ctr">
-                      <a:solidFill>
-                        <a:srgbClr val="C8CDD3"/>
-                      </a:solidFill>
-                    </a:lnL>
-                    <a:solidFill>
-                      <a:srgbClr val="FFFFFF"/>
-                    </a:solidFill>
-                  </a:tcPr>
-                </a:tc>
-                <a:tc>
-                  <a:txBody>
-                    <a:bodyPr/>
-                    <a:lstStyle/>
-                    <a:p>
-                      <a:r>
-                        <a:rPr sz="800" b="0" i="0">
-                          <a:solidFill>
-                            <a:srgbClr val="1F2937"/>
-                          </a:solidFill>
-                          <a:latin typeface="Arial"/>
-                        </a:rPr>
-                        <a:t>Re-fix the runway guard lights removed under Phase 1</a:t>
-                      </a:r>
-                    </a:p>
-                  </a:txBody>
-                  <a:tcPr marL="91440" marR="91440" marT="45720" marB="45720">
-                    <a:lnB w="6350" cap="flat" cmpd="sng" algn="ctr">
-                      <a:solidFill>
-                        <a:srgbClr val="C8CDD3"/>
-                      </a:solidFill>
-                    </a:lnB>
-                    <a:lnT w="6350" cap="flat" cmpd="sng" algn="ctr">
-                      <a:solidFill>
-                        <a:srgbClr val="C8CDD3"/>
-                      </a:solidFill>
-                    </a:lnT>
-                    <a:lnR w="6350" cap="flat" cmpd="sng" algn="ctr">
-                      <a:solidFill>
-                        <a:srgbClr val="C8CDD3"/>
-                      </a:solidFill>
-                    </a:lnR>
-                    <a:lnL w="6350" cap="flat" cmpd="sng" algn="ctr">
-                      <a:solidFill>
-                        <a:srgbClr val="C8CDD3"/>
-                      </a:solidFill>
-                    </a:lnL>
-                    <a:solidFill>
-                      <a:srgbClr val="FFFFFF"/>
-                    </a:solidFill>
-                  </a:tcPr>
-                </a:tc>
-                <a:tc>
-                  <a:txBody>
-                    <a:bodyPr/>
-                    <a:lstStyle/>
-                    <a:p>
-                      <a:r>
-                        <a:rPr sz="800" b="0" i="0">
-                          <a:solidFill>
-                            <a:srgbClr val="1F2937"/>
-                          </a:solidFill>
-                          <a:latin typeface="Arial"/>
-                        </a:rPr>
-                        <a:t>LOC-02 / 03</a:t>
-                      </a:r>
-                    </a:p>
-                  </a:txBody>
-                  <a:tcPr marL="91440" marR="91440" marT="45720" marB="45720">
-                    <a:lnB w="6350" cap="flat" cmpd="sng" algn="ctr">
-                      <a:solidFill>
-                        <a:srgbClr val="C8CDD3"/>
-                      </a:solidFill>
-                    </a:lnB>
-                    <a:lnT w="6350" cap="flat" cmpd="sng" algn="ctr">
-                      <a:solidFill>
-                        <a:srgbClr val="C8CDD3"/>
-                      </a:solidFill>
-                    </a:lnT>
-                    <a:lnR w="6350" cap="flat" cmpd="sng" algn="ctr">
-                      <a:solidFill>
-                        <a:srgbClr val="C8CDD3"/>
-                      </a:solidFill>
-                    </a:lnR>
-                    <a:lnL w="6350" cap="flat" cmpd="sng" algn="ctr">
-                      <a:solidFill>
-                        <a:srgbClr val="C8CDD3"/>
-                      </a:solidFill>
-                    </a:lnL>
-                    <a:solidFill>
-                      <a:srgbClr val="FFFFFF"/>
-                    </a:solidFill>
-                  </a:tcPr>
-                </a:tc>
-                <a:tc>
-                  <a:txBody>
-                    <a:bodyPr/>
-                    <a:lstStyle/>
-                    <a:p>
-                      <a:r>
-                        <a:rPr sz="800" b="0" i="0">
-                          <a:solidFill>
-                            <a:srgbClr val="1F2937"/>
-                          </a:solidFill>
-                          <a:latin typeface="Arial"/>
-                        </a:rPr>
-                        <a:t>3 No. RRM</a:t>
-                      </a:r>
-                    </a:p>
-                  </a:txBody>
-                  <a:tcPr marL="91440" marR="91440" marT="45720" marB="45720">
-                    <a:lnB w="6350" cap="flat" cmpd="sng" algn="ctr">
-                      <a:solidFill>
-                        <a:srgbClr val="C8CDD3"/>
-                      </a:solidFill>
-                    </a:lnB>
-                    <a:lnT w="6350" cap="flat" cmpd="sng" algn="ctr">
-                      <a:solidFill>
-                        <a:srgbClr val="C8CDD3"/>
-                      </a:solidFill>
-                    </a:lnT>
-                    <a:lnR w="6350" cap="flat" cmpd="sng" algn="ctr">
-                      <a:solidFill>
-                        <a:srgbClr val="C8CDD3"/>
-                      </a:solidFill>
-                    </a:lnR>
-                    <a:lnL w="6350" cap="flat" cmpd="sng" algn="ctr">
-                      <a:solidFill>
-                        <a:srgbClr val="C8CDD3"/>
-                      </a:solidFill>
-                    </a:lnL>
-                    <a:solidFill>
-                      <a:srgbClr val="FFFFFF"/>
-                    </a:solidFill>
-                  </a:tcPr>
-                </a:tc>
-                <a:tc>
-                  <a:txBody>
-                    <a:bodyPr/>
-                    <a:lstStyle/>
-                    <a:p>
-                      <a:r>
-                        <a:rPr sz="800" b="0" i="0">
-                          <a:solidFill>
-                            <a:srgbClr val="1F2937"/>
-                          </a:solidFill>
-                          <a:latin typeface="Arial"/>
-                        </a:rPr>
-                        <a:t>—</a:t>
-                      </a:r>
-                    </a:p>
-                  </a:txBody>
-                  <a:tcPr marL="91440" marR="91440" marT="45720" marB="45720">
-                    <a:lnB w="6350" cap="flat" cmpd="sng" algn="ctr">
-                      <a:solidFill>
-                        <a:srgbClr val="C8CDD3"/>
-                      </a:solidFill>
-                    </a:lnB>
-                    <a:lnT w="6350" cap="flat" cmpd="sng" algn="ctr">
-                      <a:solidFill>
-                        <a:srgbClr val="C8CDD3"/>
-                      </a:solidFill>
-                    </a:lnT>
-                    <a:lnR w="6350" cap="flat" cmpd="sng" algn="ctr">
-                      <a:solidFill>
-                        <a:srgbClr val="C8CDD3"/>
-                      </a:solidFill>
-                    </a:lnR>
-                    <a:lnL w="6350" cap="flat" cmpd="sng" algn="ctr">
-                      <a:solidFill>
-                        <a:srgbClr val="C8CDD3"/>
-                      </a:solidFill>
-                    </a:lnL>
-                    <a:solidFill>
-                      <a:srgbClr val="FFFFFF"/>
-                    </a:solidFill>
-                  </a:tcPr>
-                </a:tc>
-                <a:tc>
-                  <a:txBody>
-                    <a:bodyPr/>
-                    <a:lstStyle/>
-                    <a:p>
-                      <a:r>
-                        <a:rPr sz="800" b="0" i="0">
-                          <a:solidFill>
-                            <a:srgbClr val="1F2937"/>
-                          </a:solidFill>
-                          <a:latin typeface="Arial"/>
-                        </a:rPr>
-                        <a:t>RRM.555 / 557 / 670 re-fixed and aligned</a:t>
-                      </a:r>
-                    </a:p>
-                  </a:txBody>
-                  <a:tcPr marL="91440" marR="91440" marT="45720" marB="45720">
-                    <a:lnB w="6350" cap="flat" cmpd="sng" algn="ctr">
-                      <a:solidFill>
-                        <a:srgbClr val="C8CDD3"/>
-                      </a:solidFill>
-                    </a:lnB>
-                    <a:lnT w="6350" cap="flat" cmpd="sng" algn="ctr">
-                      <a:solidFill>
-                        <a:srgbClr val="C8CDD3"/>
-                      </a:solidFill>
-                    </a:lnT>
-                    <a:lnR w="6350" cap="flat" cmpd="sng" algn="ctr">
-                      <a:solidFill>
-                        <a:srgbClr val="C8CDD3"/>
-                      </a:solidFill>
-                    </a:lnR>
-                    <a:lnL w="6350" cap="flat" cmpd="sng" algn="ctr">
-                      <a:solidFill>
-                        <a:srgbClr val="C8CDD3"/>
-                      </a:solidFill>
-                    </a:lnL>
-                    <a:solidFill>
-                      <a:srgbClr val="FFFFFF"/>
-                    </a:solidFill>
-                  </a:tcPr>
-                </a:tc>
-              </a:tr>
-              <a:tr h="310413">
-                <a:tc>
-                  <a:txBody>
-                    <a:bodyPr/>
-                    <a:lstStyle/>
-                    <a:p>
-                      <a:r>
-                        <a:rPr sz="800" b="1" i="0">
-                          <a:solidFill>
-                            <a:srgbClr val="1F2937"/>
-                          </a:solidFill>
-                          <a:latin typeface="Arial"/>
-                        </a:rPr>
-                        <a:t>5</a:t>
-                      </a:r>
-                    </a:p>
-                  </a:txBody>
-                  <a:tcPr marL="91440" marR="91440" marT="45720" marB="45720">
-                    <a:lnB w="6350" cap="flat" cmpd="sng" algn="ctr">
-                      <a:solidFill>
-                        <a:srgbClr val="C8CDD3"/>
-                      </a:solidFill>
-                    </a:lnB>
-                    <a:lnT w="6350" cap="flat" cmpd="sng" algn="ctr">
-                      <a:solidFill>
-                        <a:srgbClr val="C8CDD3"/>
-                      </a:solidFill>
-                    </a:lnT>
-                    <a:lnR w="6350" cap="flat" cmpd="sng" algn="ctr">
-                      <a:solidFill>
-                        <a:srgbClr val="C8CDD3"/>
-                      </a:solidFill>
-                    </a:lnR>
-                    <a:lnL w="6350" cap="flat" cmpd="sng" algn="ctr">
-                      <a:solidFill>
-                        <a:srgbClr val="C8CDD3"/>
-                      </a:solidFill>
-                    </a:lnL>
-                    <a:solidFill>
-                      <a:srgbClr val="FFFFFF"/>
-                    </a:solidFill>
-                  </a:tcPr>
-                </a:tc>
-                <a:tc>
-                  <a:txBody>
-                    <a:bodyPr/>
-                    <a:lstStyle/>
-                    <a:p>
-                      <a:r>
-                        <a:rPr sz="800" b="0" i="0">
-                          <a:solidFill>
-                            <a:srgbClr val="1F2937"/>
-                          </a:solidFill>
-                          <a:latin typeface="Arial"/>
-                        </a:rPr>
-                        <a:t>Testing and commissioning of the affected circuits</a:t>
-                      </a:r>
-                    </a:p>
-                  </a:txBody>
-                  <a:tcPr marL="91440" marR="91440" marT="45720" marB="45720">
-                    <a:lnB w="6350" cap="flat" cmpd="sng" algn="ctr">
-                      <a:solidFill>
-                        <a:srgbClr val="C8CDD3"/>
-                      </a:solidFill>
-                    </a:lnB>
-                    <a:lnT w="6350" cap="flat" cmpd="sng" algn="ctr">
-                      <a:solidFill>
-                        <a:srgbClr val="C8CDD3"/>
-                      </a:solidFill>
-                    </a:lnT>
-                    <a:lnR w="6350" cap="flat" cmpd="sng" algn="ctr">
-                      <a:solidFill>
-                        <a:srgbClr val="C8CDD3"/>
-                      </a:solidFill>
-                    </a:lnR>
-                    <a:lnL w="6350" cap="flat" cmpd="sng" algn="ctr">
-                      <a:solidFill>
-                        <a:srgbClr val="C8CDD3"/>
-                      </a:solidFill>
-                    </a:lnL>
-                    <a:solidFill>
-                      <a:srgbClr val="FFFFFF"/>
-                    </a:solidFill>
-                  </a:tcPr>
-                </a:tc>
-                <a:tc>
-                  <a:txBody>
-                    <a:bodyPr/>
-                    <a:lstStyle/>
-                    <a:p>
-                      <a:r>
-                        <a:rPr sz="800" b="0" i="0">
-                          <a:solidFill>
-                            <a:srgbClr val="1F2937"/>
-                          </a:solidFill>
-                          <a:latin typeface="Arial"/>
-                        </a:rPr>
-                        <a:t>LOC-01 / 02 / 03</a:t>
-                      </a:r>
-                    </a:p>
-                  </a:txBody>
-                  <a:tcPr marL="91440" marR="91440" marT="45720" marB="45720">
-                    <a:lnB w="6350" cap="flat" cmpd="sng" algn="ctr">
-                      <a:solidFill>
-                        <a:srgbClr val="C8CDD3"/>
-                      </a:solidFill>
-                    </a:lnB>
-                    <a:lnT w="6350" cap="flat" cmpd="sng" algn="ctr">
-                      <a:solidFill>
-                        <a:srgbClr val="C8CDD3"/>
-                      </a:solidFill>
-                    </a:lnT>
-                    <a:lnR w="6350" cap="flat" cmpd="sng" algn="ctr">
-                      <a:solidFill>
-                        <a:srgbClr val="C8CDD3"/>
-                      </a:solidFill>
-                    </a:lnR>
-                    <a:lnL w="6350" cap="flat" cmpd="sng" algn="ctr">
-                      <a:solidFill>
-                        <a:srgbClr val="C8CDD3"/>
-                      </a:solidFill>
-                    </a:lnL>
-                    <a:solidFill>
-                      <a:srgbClr val="FFFFFF"/>
-                    </a:solidFill>
-                  </a:tcPr>
-                </a:tc>
-                <a:tc>
-                  <a:txBody>
-                    <a:bodyPr/>
-                    <a:lstStyle/>
-                    <a:p>
-                      <a:r>
-                        <a:rPr sz="800" b="0" i="0">
-                          <a:solidFill>
-                            <a:srgbClr val="1F2937"/>
-                          </a:solidFill>
-                          <a:latin typeface="Arial"/>
-                        </a:rPr>
-                        <a:t>4 No. circuits</a:t>
-                      </a:r>
-                    </a:p>
-                  </a:txBody>
-                  <a:tcPr marL="91440" marR="91440" marT="45720" marB="45720">
-                    <a:lnB w="6350" cap="flat" cmpd="sng" algn="ctr">
-                      <a:solidFill>
-                        <a:srgbClr val="C8CDD3"/>
-                      </a:solidFill>
-                    </a:lnB>
-                    <a:lnT w="6350" cap="flat" cmpd="sng" algn="ctr">
-                      <a:solidFill>
-                        <a:srgbClr val="C8CDD3"/>
-                      </a:solidFill>
-                    </a:lnT>
-                    <a:lnR w="6350" cap="flat" cmpd="sng" algn="ctr">
-                      <a:solidFill>
-                        <a:srgbClr val="C8CDD3"/>
-                      </a:solidFill>
-                    </a:lnR>
-                    <a:lnL w="6350" cap="flat" cmpd="sng" algn="ctr">
-                      <a:solidFill>
-                        <a:srgbClr val="C8CDD3"/>
-                      </a:solidFill>
-                    </a:lnL>
-                    <a:solidFill>
-                      <a:srgbClr val="FFFFFF"/>
-                    </a:solidFill>
-                  </a:tcPr>
-                </a:tc>
-                <a:tc>
-                  <a:txBody>
-                    <a:bodyPr/>
-                    <a:lstStyle/>
-                    <a:p>
-                      <a:r>
-                        <a:rPr sz="800" b="0" i="0">
-                          <a:solidFill>
-                            <a:srgbClr val="1F2937"/>
-                          </a:solidFill>
-                          <a:latin typeface="Arial"/>
-                        </a:rPr>
-                        <a:t>—</a:t>
-                      </a:r>
-                    </a:p>
-                  </a:txBody>
-                  <a:tcPr marL="91440" marR="91440" marT="45720" marB="45720">
-                    <a:lnB w="6350" cap="flat" cmpd="sng" algn="ctr">
-                      <a:solidFill>
-                        <a:srgbClr val="C8CDD3"/>
-                      </a:solidFill>
-                    </a:lnB>
-                    <a:lnT w="6350" cap="flat" cmpd="sng" algn="ctr">
-                      <a:solidFill>
-                        <a:srgbClr val="C8CDD3"/>
-                      </a:solidFill>
-                    </a:lnT>
-                    <a:lnR w="6350" cap="flat" cmpd="sng" algn="ctr">
-                      <a:solidFill>
-                        <a:srgbClr val="C8CDD3"/>
-                      </a:solidFill>
-                    </a:lnR>
-                    <a:lnL w="6350" cap="flat" cmpd="sng" algn="ctr">
-                      <a:solidFill>
-                        <a:srgbClr val="C8CDD3"/>
-                      </a:solidFill>
-                    </a:lnL>
-                    <a:solidFill>
-                      <a:srgbClr val="FFFFFF"/>
-                    </a:solidFill>
-                  </a:tcPr>
-                </a:tc>
-                <a:tc>
-                  <a:txBody>
-                    <a:bodyPr/>
-                    <a:lstStyle/>
-                    <a:p>
-                      <a:r>
-                        <a:rPr sz="800" b="0" i="0">
-                          <a:solidFill>
-                            <a:srgbClr val="1F2937"/>
-                          </a:solidFill>
-                          <a:latin typeface="Arial"/>
-                        </a:rPr>
-                        <a:t>Circuits energised and proved</a:t>
-                      </a:r>
-                    </a:p>
-                  </a:txBody>
-                  <a:tcPr marL="91440" marR="91440" marT="45720" marB="45720">
-                    <a:lnB w="6350" cap="flat" cmpd="sng" algn="ctr">
-                      <a:solidFill>
-                        <a:srgbClr val="C8CDD3"/>
-                      </a:solidFill>
-                    </a:lnB>
-                    <a:lnT w="6350" cap="flat" cmpd="sng" algn="ctr">
-                      <a:solidFill>
-                        <a:srgbClr val="C8CDD3"/>
-                      </a:solidFill>
-                    </a:lnT>
-                    <a:lnR w="6350" cap="flat" cmpd="sng" algn="ctr">
-                      <a:solidFill>
-                        <a:srgbClr val="C8CDD3"/>
-                      </a:solidFill>
-                    </a:lnR>
-                    <a:lnL w="6350" cap="flat" cmpd="sng" algn="ctr">
-                      <a:solidFill>
-                        <a:srgbClr val="C8CDD3"/>
-                      </a:solidFill>
-                    </a:lnL>
-                    <a:solidFill>
-                      <a:srgbClr val="FFFFFF"/>
-                    </a:solidFill>
-                  </a:tcPr>
-                </a:tc>
-              </a:tr>
-              <a:tr h="310413">
-                <a:tc>
-                  <a:txBody>
-                    <a:bodyPr/>
-                    <a:lstStyle/>
-                    <a:p>
-                      <a:r>
-                        <a:rPr sz="800" b="1" i="0">
-                          <a:solidFill>
-                            <a:srgbClr val="1F2937"/>
-                          </a:solidFill>
-                          <a:latin typeface="Arial"/>
-                        </a:rPr>
-                        <a:t>5</a:t>
-                      </a:r>
-                    </a:p>
-                  </a:txBody>
-                  <a:tcPr marL="91440" marR="91440" marT="45720" marB="45720">
-                    <a:lnB w="6350" cap="flat" cmpd="sng" algn="ctr">
-                      <a:solidFill>
-                        <a:srgbClr val="C8CDD3"/>
-                      </a:solidFill>
-                    </a:lnB>
-                    <a:lnT w="6350" cap="flat" cmpd="sng" algn="ctr">
-                      <a:solidFill>
-                        <a:srgbClr val="C8CDD3"/>
-                      </a:solidFill>
-                    </a:lnT>
-                    <a:lnR w="6350" cap="flat" cmpd="sng" algn="ctr">
-                      <a:solidFill>
-                        <a:srgbClr val="C8CDD3"/>
-                      </a:solidFill>
-                    </a:lnR>
-                    <a:lnL w="6350" cap="flat" cmpd="sng" algn="ctr">
-                      <a:solidFill>
-                        <a:srgbClr val="C8CDD3"/>
-                      </a:solidFill>
-                    </a:lnL>
-                    <a:solidFill>
-                      <a:srgbClr val="FFFFFF"/>
-                    </a:solidFill>
-                  </a:tcPr>
-                </a:tc>
-                <a:tc>
-                  <a:txBody>
-                    <a:bodyPr/>
-                    <a:lstStyle/>
-                    <a:p>
-                      <a:r>
-                        <a:rPr sz="800" b="0" i="0">
-                          <a:solidFill>
-                            <a:srgbClr val="1F2937"/>
-                          </a:solidFill>
-                          <a:latin typeface="Arial"/>
-                        </a:rPr>
-                        <a:t>Final functionality check, then handover to Operations</a:t>
-                      </a:r>
-                    </a:p>
-                  </a:txBody>
-                  <a:tcPr marL="91440" marR="91440" marT="45720" marB="45720">
-                    <a:lnB w="6350" cap="flat" cmpd="sng" algn="ctr">
-                      <a:solidFill>
-                        <a:srgbClr val="C8CDD3"/>
-                      </a:solidFill>
-                    </a:lnB>
-                    <a:lnT w="6350" cap="flat" cmpd="sng" algn="ctr">
-                      <a:solidFill>
-                        <a:srgbClr val="C8CDD3"/>
-                      </a:solidFill>
-                    </a:lnT>
-                    <a:lnR w="6350" cap="flat" cmpd="sng" algn="ctr">
-                      <a:solidFill>
-                        <a:srgbClr val="C8CDD3"/>
-                      </a:solidFill>
-                    </a:lnR>
-                    <a:lnL w="6350" cap="flat" cmpd="sng" algn="ctr">
-                      <a:solidFill>
-                        <a:srgbClr val="C8CDD3"/>
-                      </a:solidFill>
-                    </a:lnL>
-                    <a:solidFill>
-                      <a:srgbClr val="FFFFFF"/>
-                    </a:solidFill>
-                  </a:tcPr>
-                </a:tc>
-                <a:tc>
-                  <a:txBody>
-                    <a:bodyPr/>
-                    <a:lstStyle/>
-                    <a:p>
-                      <a:r>
-                        <a:rPr sz="800" b="0" i="0">
-                          <a:solidFill>
-                            <a:srgbClr val="1F2937"/>
-                          </a:solidFill>
-                          <a:latin typeface="Arial"/>
-                        </a:rPr>
-                        <a:t>LOC-01 / 02 / 03</a:t>
-                      </a:r>
-                    </a:p>
-                  </a:txBody>
-                  <a:tcPr marL="91440" marR="91440" marT="45720" marB="45720">
-                    <a:lnB w="6350" cap="flat" cmpd="sng" algn="ctr">
-                      <a:solidFill>
-                        <a:srgbClr val="C8CDD3"/>
-                      </a:solidFill>
-                    </a:lnB>
-                    <a:lnT w="6350" cap="flat" cmpd="sng" algn="ctr">
-                      <a:solidFill>
-                        <a:srgbClr val="C8CDD3"/>
-                      </a:solidFill>
-                    </a:lnT>
-                    <a:lnR w="6350" cap="flat" cmpd="sng" algn="ctr">
-                      <a:solidFill>
-                        <a:srgbClr val="C8CDD3"/>
-                      </a:solidFill>
-                    </a:lnR>
-                    <a:lnL w="6350" cap="flat" cmpd="sng" algn="ctr">
-                      <a:solidFill>
-                        <a:srgbClr val="C8CDD3"/>
-                      </a:solidFill>
-                    </a:lnL>
-                    <a:solidFill>
-                      <a:srgbClr val="FFFFFF"/>
-                    </a:solidFill>
-                  </a:tcPr>
-                </a:tc>
-                <a:tc>
-                  <a:txBody>
-                    <a:bodyPr/>
-                    <a:lstStyle/>
-                    <a:p>
-                      <a:r>
-                        <a:rPr sz="800" b="0" i="0">
-                          <a:solidFill>
-                            <a:srgbClr val="1F2937"/>
-                          </a:solidFill>
-                          <a:latin typeface="Arial"/>
-                        </a:rPr>
                         <a:t>16 No. fittings</a:t>
                       </a:r>
                     </a:p>
@@ -57953,8 +58207,8 @@
         </p:nvSpPr>
         <p:spPr>
           <a:xfrm>
-            <a:off x="457200" y="7581519"/>
-            <a:ext cx="6958584" cy="2438781"/>
+            <a:off x="457200" y="6788404"/>
+            <a:ext cx="6958584" cy="3231896"/>
           </a:xfrm>
           <a:prstGeom prst="rect">
             <a:avLst/>
@@ -57999,7 +58253,7 @@
         </p:nvSpPr>
         <p:spPr>
           <a:xfrm>
-            <a:off x="603504" y="7691247"/>
+            <a:off x="603504" y="6898132"/>
             <a:ext cx="6665976" cy="237744"/>
           </a:xfrm>
           <a:prstGeom prst="rect">
@@ -58038,8 +58292,8 @@
         </p:nvSpPr>
         <p:spPr>
           <a:xfrm>
-            <a:off x="603504" y="8057007"/>
-            <a:ext cx="6665976" cy="1826133"/>
+            <a:off x="603504" y="7263892"/>
+            <a:ext cx="6665976" cy="2619248"/>
           </a:xfrm>
           <a:prstGeom prst="rect">
             <a:avLst/>
@@ -58141,8 +58395,8 @@
         </p:nvSpPr>
         <p:spPr>
           <a:xfrm>
-            <a:off x="7699248" y="7581519"/>
-            <a:ext cx="6958584" cy="2438781"/>
+            <a:off x="7699248" y="6788404"/>
+            <a:ext cx="6958584" cy="3231896"/>
           </a:xfrm>
           <a:prstGeom prst="rect">
             <a:avLst/>
@@ -58187,7 +58441,7 @@
         </p:nvSpPr>
         <p:spPr>
           <a:xfrm>
-            <a:off x="7845552" y="7691247"/>
+            <a:off x="7845552" y="6898132"/>
             <a:ext cx="6665976" cy="237744"/>
           </a:xfrm>
           <a:prstGeom prst="rect">
@@ -58226,8 +58480,8 @@
         </p:nvSpPr>
         <p:spPr>
           <a:xfrm>
-            <a:off x="7845552" y="8057007"/>
-            <a:ext cx="6665976" cy="1826133"/>
+            <a:off x="7845552" y="7263892"/>
+            <a:ext cx="6665976" cy="2619248"/>
           </a:xfrm>
           <a:prstGeom prst="rect">
             <a:avLst/>
@@ -58253,6 +58507,38 @@
                 <a:latin typeface="Arial"/>
               </a:rPr>
               <a:t>Covers Phase 3 AGL installation only. Phase 1 asset removal and coring is recorded complete (site record 23.07.2026); Phase 2 civil attendance sits outside these five days.</a:t>
+            </a:r>
+          </a:p>
+          <a:p>
+            <a:pPr>
+              <a:spcAft>
+                <a:spcPts val="400"/>
+              </a:spcAft>
+            </a:pPr>
+            <a:r>
+              <a:rPr sz="900" b="0" i="0">
+                <a:solidFill>
+                  <a:srgbClr val="1F2937"/>
+                </a:solidFill>
+                <a:latin typeface="Arial"/>
+              </a:rPr>
+              <a:t>The three locations are worked one front at a time — LOC-01 over Days 1–3, LOC-03 on Day 4, LOC-02 on Day 5 — so each is cut, cabled, tested and sealed before the next is opened. Days are allocated to the work each location carries: 11 No. fittings and approx. 300 m of cut at LOC-01, 4 No. and approx. 95 m at LOC-03, 1 No. and approx. 24 m at LOC-02.</a:t>
+            </a:r>
+          </a:p>
+          <a:p>
+            <a:pPr>
+              <a:spcAft>
+                <a:spcPts val="400"/>
+              </a:spcAft>
+            </a:pPr>
+            <a:r>
+              <a:rPr sz="900" b="0" i="0">
+                <a:solidFill>
+                  <a:srgbClr val="1F2937"/>
+                </a:solidFill>
+                <a:latin typeface="Arial"/>
+              </a:rPr>
+              <a:t>Only two items span all three locations: the setting-out on Day 1, taken in one survey visit, and the circuit testing and commissioning on Day 5, which cannot complete until every location is cabled because the circuits run through all three.</a:t>
             </a:r>
           </a:p>
           <a:p>

</xml_diff>